<commit_message>
feat: enhance Obsidian Gold PPTX with real code snippets, line numbers, and live demo cheat sheet
</commit_message>
<xml_diff>
--- a/Week_1_Presentation_Obsidian_Gold.pptx
+++ b/Week_1_Presentation_Obsidian_Gold.pptx
@@ -14,6 +14,7 @@
     <p:sldId id="262" r:id="rId13"/>
     <p:sldId id="263" r:id="rId14"/>
     <p:sldId id="264" r:id="rId15"/>
+    <p:sldId id="265" r:id="rId16"/>
   </p:sldIdLst>
   <p:sldSz cx="12191695" cy="6858000" type="screen4x3"/>
   <p:notesSz cx="6858000" cy="9144000"/>
@@ -3217,7 +3218,7 @@
               </a:defRPr>
             </a:pPr>
             <a:r>
-              <a:t>1-MONTH WEB DEVELOPMENT TRAINING • PRESENTATION #1</a:t>
+              <a:t>1-MONTH FULL-STACK TRAINING • WEEK 1 REVIEW &amp; DEMO</a:t>
             </a:r>
           </a:p>
           <a:p>
@@ -3242,7 +3243,7 @@
           <a:p>
             <a:pPr>
               <a:spcAft>
-                <a:spcPts val="2800"/>
+                <a:spcPts val="2400"/>
               </a:spcAft>
               <a:defRPr sz="1500">
                 <a:solidFill>
@@ -3251,7 +3252,11 @@
               </a:defRPr>
             </a:pPr>
             <a:r>
-              <a:t>Full Architecture Breakdown: Semantic Layouts, Professional Git Workflows, Asynchronous Event Loop, DOM Event Delegation &amp; Node.js Core.</a:t>
+              <a:t>Comprehensive Architectural Walkthrough with Exact Code Snippets &amp; Line Numbers:</a:t>
+            </a:r>
+            <a:br/>
+            <a:r>
+              <a:t>Semantic HTML5, CSS Grid/Flexbox, Event Loop, Event Delegation, LocalStorage &amp; Node.js Core.</a:t>
             </a:r>
           </a:p>
           <a:p>
@@ -3266,7 +3271,7 @@
               </a:defRPr>
             </a:pPr>
             <a:r>
-              <a:t>🚀 FEATURED LIVE DEMO: DevExplorer PRO v2.0 (GitHub Analytics &amp; Bookmark Manager)</a:t>
+              <a:t>🚀 FEATURED LIVE MINI-PROJECT: DevExplorer PRO v2.0 (GitHub Analytics &amp; Bookmark Manager)</a:t>
             </a:r>
           </a:p>
           <a:p>
@@ -3279,6 +3284,586 @@
             </a:pPr>
             <a:r>
               <a:t>Presenter: Full-Stack Engineering Trainee  |  Date: August 10, 2026</a:t>
+            </a:r>
+          </a:p>
+        </p:txBody>
+      </p:sp>
+    </p:spTree>
+  </p:cSld>
+  <p:clrMapOvr>
+    <a:masterClrMapping/>
+  </p:clrMapOvr>
+</p:sld>
+</file>
+
+<file path=ppt/slides/slide10.xml><?xml version="1.0" encoding="utf-8"?>
+<p:sld xmlns:a="http://schemas.openxmlformats.org/drawingml/2006/main" xmlns:p="http://schemas.openxmlformats.org/presentationml/2006/main" xmlns:r="http://schemas.openxmlformats.org/officeDocument/2006/relationships">
+  <p:cSld>
+    <p:spTree>
+      <p:nvGrpSpPr>
+        <p:cNvPr id="1" name=""/>
+        <p:cNvGrpSpPr/>
+        <p:nvPr/>
+      </p:nvGrpSpPr>
+      <p:grpSpPr/>
+      <p:sp>
+        <p:nvSpPr>
+          <p:cNvPr id="2" name="Rectangle 1"/>
+          <p:cNvSpPr/>
+          <p:nvPr/>
+        </p:nvSpPr>
+        <p:spPr>
+          <a:xfrm>
+            <a:off x="0" y="0"/>
+            <a:ext cx="12191695" cy="6858000"/>
+          </a:xfrm>
+          <a:prstGeom prst="rect">
+            <a:avLst/>
+          </a:prstGeom>
+          <a:solidFill>
+            <a:srgbClr val="121214"/>
+          </a:solidFill>
+          <a:ln>
+            <a:noFill/>
+          </a:ln>
+        </p:spPr>
+        <p:style>
+          <a:lnRef idx="1">
+            <a:schemeClr val="accent1"/>
+          </a:lnRef>
+          <a:fillRef idx="3">
+            <a:schemeClr val="accent1"/>
+          </a:fillRef>
+          <a:effectRef idx="2">
+            <a:schemeClr val="accent1"/>
+          </a:effectRef>
+          <a:fontRef idx="minor">
+            <a:schemeClr val="lt1"/>
+          </a:fontRef>
+        </p:style>
+        <p:txBody>
+          <a:bodyPr rtlCol="0" anchor="ctr"/>
+          <a:lstStyle/>
+          <a:p>
+            <a:pPr algn="ctr"/>
+          </a:p>
+        </p:txBody>
+      </p:sp>
+      <p:sp>
+        <p:nvSpPr>
+          <p:cNvPr id="3" name="TextBox 2"/>
+          <p:cNvSpPr txBox="1"/>
+          <p:nvPr/>
+        </p:nvSpPr>
+        <p:spPr>
+          <a:xfrm>
+            <a:off x="731520" y="365760"/>
+            <a:ext cx="7315200" cy="320040"/>
+          </a:xfrm>
+          <a:prstGeom prst="rect">
+            <a:avLst/>
+          </a:prstGeom>
+          <a:noFill/>
+        </p:spPr>
+        <p:txBody>
+          <a:bodyPr wrap="square" lIns="0" tIns="0" rIns="0" bIns="0">
+            <a:spAutoFit/>
+          </a:bodyPr>
+          <a:lstStyle/>
+          <a:p>
+            <a:pPr>
+              <a:defRPr sz="1100" b="1">
+                <a:solidFill>
+                  <a:srgbClr val="F59E0B"/>
+                </a:solidFill>
+              </a:defRPr>
+            </a:pPr>
+            <a:r>
+              <a:t>LOOKING FORWARD</a:t>
+            </a:r>
+          </a:p>
+        </p:txBody>
+      </p:sp>
+      <p:sp>
+        <p:nvSpPr>
+          <p:cNvPr id="4" name="TextBox 3"/>
+          <p:cNvSpPr txBox="1"/>
+          <p:nvPr/>
+        </p:nvSpPr>
+        <p:spPr>
+          <a:xfrm>
+            <a:off x="731520" y="658368"/>
+            <a:ext cx="10698480" cy="548640"/>
+          </a:xfrm>
+          <a:prstGeom prst="rect">
+            <a:avLst/>
+          </a:prstGeom>
+          <a:noFill/>
+        </p:spPr>
+        <p:txBody>
+          <a:bodyPr wrap="square" lIns="0" tIns="0" rIns="0" bIns="0">
+            <a:spAutoFit/>
+          </a:bodyPr>
+          <a:lstStyle/>
+          <a:p>
+            <a:pPr>
+              <a:defRPr sz="2300" b="1">
+                <a:solidFill>
+                  <a:srgbClr val="FFFFFF"/>
+                </a:solidFill>
+              </a:defRPr>
+            </a:pPr>
+            <a:r>
+              <a:t>Summary, Key Learnings &amp; Next Steps</a:t>
+            </a:r>
+          </a:p>
+        </p:txBody>
+      </p:sp>
+      <p:sp>
+        <p:nvSpPr>
+          <p:cNvPr id="5" name="Rectangle 4"/>
+          <p:cNvSpPr/>
+          <p:nvPr/>
+        </p:nvSpPr>
+        <p:spPr>
+          <a:xfrm>
+            <a:off x="731520" y="1234440"/>
+            <a:ext cx="10728655" cy="13716"/>
+          </a:xfrm>
+          <a:prstGeom prst="rect">
+            <a:avLst/>
+          </a:prstGeom>
+          <a:solidFill>
+            <a:srgbClr val="2A2A32"/>
+          </a:solidFill>
+          <a:ln>
+            <a:noFill/>
+          </a:ln>
+        </p:spPr>
+        <p:style>
+          <a:lnRef idx="1">
+            <a:schemeClr val="accent1"/>
+          </a:lnRef>
+          <a:fillRef idx="3">
+            <a:schemeClr val="accent1"/>
+          </a:fillRef>
+          <a:effectRef idx="2">
+            <a:schemeClr val="accent1"/>
+          </a:effectRef>
+          <a:fontRef idx="minor">
+            <a:schemeClr val="lt1"/>
+          </a:fontRef>
+        </p:style>
+        <p:txBody>
+          <a:bodyPr rtlCol="0" anchor="ctr"/>
+          <a:lstStyle/>
+          <a:p>
+            <a:pPr algn="ctr"/>
+          </a:p>
+        </p:txBody>
+      </p:sp>
+      <p:sp>
+        <p:nvSpPr>
+          <p:cNvPr id="6" name="Rounded Rectangle 5"/>
+          <p:cNvSpPr/>
+          <p:nvPr/>
+        </p:nvSpPr>
+        <p:spPr>
+          <a:xfrm>
+            <a:off x="731520" y="1463040"/>
+            <a:ext cx="5212080" cy="4846320"/>
+          </a:xfrm>
+          <a:prstGeom prst="roundRect">
+            <a:avLst/>
+          </a:prstGeom>
+          <a:solidFill>
+            <a:srgbClr val="1A1A1E"/>
+          </a:solidFill>
+          <a:ln w="12700">
+            <a:solidFill>
+              <a:srgbClr val="2A2A32"/>
+            </a:solidFill>
+          </a:ln>
+        </p:spPr>
+        <p:style>
+          <a:lnRef idx="1">
+            <a:schemeClr val="accent1"/>
+          </a:lnRef>
+          <a:fillRef idx="3">
+            <a:schemeClr val="accent1"/>
+          </a:fillRef>
+          <a:effectRef idx="2">
+            <a:schemeClr val="accent1"/>
+          </a:effectRef>
+          <a:fontRef idx="minor">
+            <a:schemeClr val="lt1"/>
+          </a:fontRef>
+        </p:style>
+        <p:txBody>
+          <a:bodyPr rtlCol="0" anchor="ctr"/>
+          <a:lstStyle/>
+          <a:p>
+            <a:pPr algn="ctr"/>
+          </a:p>
+        </p:txBody>
+      </p:sp>
+      <p:sp>
+        <p:nvSpPr>
+          <p:cNvPr id="7" name="TextBox 6"/>
+          <p:cNvSpPr txBox="1"/>
+          <p:nvPr/>
+        </p:nvSpPr>
+        <p:spPr>
+          <a:xfrm>
+            <a:off x="1005840" y="1645920"/>
+            <a:ext cx="4663440" cy="4389120"/>
+          </a:xfrm>
+          <a:prstGeom prst="rect">
+            <a:avLst/>
+          </a:prstGeom>
+          <a:noFill/>
+        </p:spPr>
+        <p:txBody>
+          <a:bodyPr wrap="square" lIns="0" tIns="0" rIns="0" bIns="0">
+            <a:spAutoFit/>
+          </a:bodyPr>
+          <a:lstStyle/>
+          <a:p>
+            <a:pPr>
+              <a:spcAft>
+                <a:spcPts val="1400"/>
+              </a:spcAft>
+              <a:defRPr sz="1700" b="1">
+                <a:solidFill>
+                  <a:srgbClr val="FFFFFF"/>
+                </a:solidFill>
+              </a:defRPr>
+            </a:pPr>
+            <a:r>
+              <a:t>Week 1 Core Learnings</a:t>
+            </a:r>
+          </a:p>
+          <a:p>
+            <a:pPr>
+              <a:spcAft>
+                <a:spcPts val="200"/>
+              </a:spcAft>
+              <a:defRPr sz="1200" b="1">
+                <a:solidFill>
+                  <a:srgbClr val="FCD34D"/>
+                </a:solidFill>
+              </a:defRPr>
+            </a:pPr>
+            <a:r>
+              <a:t>✔  Production Web Standards</a:t>
+            </a:r>
+          </a:p>
+          <a:p>
+            <a:pPr>
+              <a:spcAft>
+                <a:spcPts val="1000"/>
+              </a:spcAft>
+              <a:defRPr sz="1050">
+                <a:solidFill>
+                  <a:srgbClr val="E4E4E7"/>
+                </a:solidFill>
+              </a:defRPr>
+            </a:pPr>
+            <a:r>
+              <a:t>Adopted Semantic HTML5, 1D Flexbox, and 2D Auto-responsive CSS Grid.</a:t>
+            </a:r>
+          </a:p>
+          <a:p>
+            <a:pPr>
+              <a:spcAft>
+                <a:spcPts val="200"/>
+              </a:spcAft>
+              <a:defRPr sz="1200" b="1">
+                <a:solidFill>
+                  <a:srgbClr val="FCD34D"/>
+                </a:solidFill>
+              </a:defRPr>
+            </a:pPr>
+            <a:r>
+              <a:t>✔  Advanced JS &amp; Event Loop</a:t>
+            </a:r>
+          </a:p>
+          <a:p>
+            <a:pPr>
+              <a:spcAft>
+                <a:spcPts val="1000"/>
+              </a:spcAft>
+              <a:defRPr sz="1050">
+                <a:solidFill>
+                  <a:srgbClr val="E4E4E7"/>
+                </a:solidFill>
+              </a:defRPr>
+            </a:pPr>
+            <a:r>
+              <a:t>Learned block scoping, immutability, Microtasks vs Macrotasks, and Promise concurrency.</a:t>
+            </a:r>
+          </a:p>
+          <a:p>
+            <a:pPr>
+              <a:spcAft>
+                <a:spcPts val="200"/>
+              </a:spcAft>
+              <a:defRPr sz="1200" b="1">
+                <a:solidFill>
+                  <a:srgbClr val="FCD34D"/>
+                </a:solidFill>
+              </a:defRPr>
+            </a:pPr>
+            <a:r>
+              <a:t>✔  Event Delegation Architecture</a:t>
+            </a:r>
+          </a:p>
+          <a:p>
+            <a:pPr>
+              <a:spcAft>
+                <a:spcPts val="1000"/>
+              </a:spcAft>
+              <a:defRPr sz="1050">
+                <a:solidFill>
+                  <a:srgbClr val="E4E4E7"/>
+                </a:solidFill>
+              </a:defRPr>
+            </a:pPr>
+            <a:r>
+              <a:t>Eliminated memory leaks using single parent container listeners with closest().</a:t>
+            </a:r>
+          </a:p>
+          <a:p>
+            <a:pPr>
+              <a:spcAft>
+                <a:spcPts val="200"/>
+              </a:spcAft>
+              <a:defRPr sz="1200" b="1">
+                <a:solidFill>
+                  <a:srgbClr val="FCD34D"/>
+                </a:solidFill>
+              </a:defRPr>
+            </a:pPr>
+            <a:r>
+              <a:t>✔  Server-Side Node.js Runtime</a:t>
+            </a:r>
+          </a:p>
+          <a:p>
+            <a:pPr>
+              <a:spcAft>
+                <a:spcPts val="1000"/>
+              </a:spcAft>
+              <a:defRPr sz="1050">
+                <a:solidFill>
+                  <a:srgbClr val="E4E4E7"/>
+                </a:solidFill>
+              </a:defRPr>
+            </a:pPr>
+            <a:r>
+              <a:t>Understood V8 engine, Libuv thread pool, and non-blocking fs/promises disk I/O.</a:t>
+            </a:r>
+          </a:p>
+        </p:txBody>
+      </p:sp>
+      <p:sp>
+        <p:nvSpPr>
+          <p:cNvPr id="8" name="Rounded Rectangle 7"/>
+          <p:cNvSpPr/>
+          <p:nvPr/>
+        </p:nvSpPr>
+        <p:spPr>
+          <a:xfrm>
+            <a:off x="6217920" y="1463040"/>
+            <a:ext cx="5242255" cy="4846320"/>
+          </a:xfrm>
+          <a:prstGeom prst="roundRect">
+            <a:avLst/>
+          </a:prstGeom>
+          <a:solidFill>
+            <a:srgbClr val="1A1A1E"/>
+          </a:solidFill>
+          <a:ln w="12700">
+            <a:solidFill>
+              <a:srgbClr val="2A2A32"/>
+            </a:solidFill>
+          </a:ln>
+        </p:spPr>
+        <p:style>
+          <a:lnRef idx="1">
+            <a:schemeClr val="accent1"/>
+          </a:lnRef>
+          <a:fillRef idx="3">
+            <a:schemeClr val="accent1"/>
+          </a:fillRef>
+          <a:effectRef idx="2">
+            <a:schemeClr val="accent1"/>
+          </a:effectRef>
+          <a:fontRef idx="minor">
+            <a:schemeClr val="lt1"/>
+          </a:fontRef>
+        </p:style>
+        <p:txBody>
+          <a:bodyPr rtlCol="0" anchor="ctr"/>
+          <a:lstStyle/>
+          <a:p>
+            <a:pPr algn="ctr"/>
+          </a:p>
+        </p:txBody>
+      </p:sp>
+      <p:sp>
+        <p:nvSpPr>
+          <p:cNvPr id="9" name="TextBox 8"/>
+          <p:cNvSpPr txBox="1"/>
+          <p:nvPr/>
+        </p:nvSpPr>
+        <p:spPr>
+          <a:xfrm>
+            <a:off x="6492240" y="1645920"/>
+            <a:ext cx="4663440" cy="4389120"/>
+          </a:xfrm>
+          <a:prstGeom prst="rect">
+            <a:avLst/>
+          </a:prstGeom>
+          <a:noFill/>
+        </p:spPr>
+        <p:txBody>
+          <a:bodyPr wrap="square" lIns="0" tIns="0" rIns="0" bIns="0">
+            <a:spAutoFit/>
+          </a:bodyPr>
+          <a:lstStyle/>
+          <a:p>
+            <a:pPr>
+              <a:spcAft>
+                <a:spcPts val="1400"/>
+              </a:spcAft>
+              <a:defRPr sz="1700" b="1">
+                <a:solidFill>
+                  <a:srgbClr val="F59E0B"/>
+                </a:solidFill>
+              </a:defRPr>
+            </a:pPr>
+            <a:r>
+              <a:t>Week 2: React Deep Dive Roadmap</a:t>
+            </a:r>
+          </a:p>
+          <a:p>
+            <a:pPr>
+              <a:spcAft>
+                <a:spcPts val="200"/>
+              </a:spcAft>
+              <a:defRPr sz="1200" b="1">
+                <a:solidFill>
+                  <a:srgbClr val="FCD34D"/>
+                </a:solidFill>
+              </a:defRPr>
+            </a:pPr>
+            <a:r>
+              <a:t>🚀  Thinking in React &amp; JSX (Day 01)</a:t>
+            </a:r>
+          </a:p>
+          <a:p>
+            <a:pPr>
+              <a:spcAft>
+                <a:spcPts val="1000"/>
+              </a:spcAft>
+              <a:defRPr sz="1050">
+                <a:solidFill>
+                  <a:srgbClr val="E4E4E7"/>
+                </a:solidFill>
+              </a:defRPr>
+            </a:pPr>
+            <a:r>
+              <a:t>Component hierarchies, JSX compilation rules, and Props vs State architecture.</a:t>
+            </a:r>
+          </a:p>
+          <a:p>
+            <a:pPr>
+              <a:spcAft>
+                <a:spcPts val="200"/>
+              </a:spcAft>
+              <a:defRPr sz="1200" b="1">
+                <a:solidFill>
+                  <a:srgbClr val="FCD34D"/>
+                </a:solidFill>
+              </a:defRPr>
+            </a:pPr>
+            <a:r>
+              <a:t>🚀  Interactive State &amp; Hooks (Day 02)</a:t>
+            </a:r>
+          </a:p>
+          <a:p>
+            <a:pPr>
+              <a:spcAft>
+                <a:spcPts val="1000"/>
+              </a:spcAft>
+              <a:defRPr sz="1050">
+                <a:solidFill>
+                  <a:srgbClr val="E4E4E7"/>
+                </a:solidFill>
+              </a:defRPr>
+            </a:pPr>
+            <a:r>
+              <a:t>useState mechanics, immutable state updates, and building a modular Tic-Tac-Toe game.</a:t>
+            </a:r>
+          </a:p>
+          <a:p>
+            <a:pPr>
+              <a:spcAft>
+                <a:spcPts val="200"/>
+              </a:spcAft>
+              <a:defRPr sz="1200" b="1">
+                <a:solidFill>
+                  <a:srgbClr val="FCD34D"/>
+                </a:solidFill>
+              </a:defRPr>
+            </a:pPr>
+            <a:r>
+              <a:t>🚀  Effects &amp; Custom Hooks (Day 03)</a:t>
+            </a:r>
+          </a:p>
+          <a:p>
+            <a:pPr>
+              <a:spcAft>
+                <a:spcPts val="1000"/>
+              </a:spcAft>
+              <a:defRPr sz="1050">
+                <a:solidFill>
+                  <a:srgbClr val="E4E4E7"/>
+                </a:solidFill>
+              </a:defRPr>
+            </a:pPr>
+            <a:r>
+              <a:t>useEffect lifecycle management, dependency arrays, cleanup functions, and custom API hooks.</a:t>
+            </a:r>
+          </a:p>
+          <a:p>
+            <a:pPr>
+              <a:spcAft>
+                <a:spcPts val="200"/>
+              </a:spcAft>
+              <a:defRPr sz="1200" b="1">
+                <a:solidFill>
+                  <a:srgbClr val="FCD34D"/>
+                </a:solidFill>
+              </a:defRPr>
+            </a:pPr>
+            <a:r>
+              <a:t>🚀  Context API &amp; Mini-Project (Day 04)</a:t>
+            </a:r>
+          </a:p>
+          <a:p>
+            <a:pPr>
+              <a:spcAft>
+                <a:spcPts val="1000"/>
+              </a:spcAft>
+              <a:defRPr sz="1050">
+                <a:solidFill>
+                  <a:srgbClr val="E4E4E7"/>
+                </a:solidFill>
+              </a:defRPr>
+            </a:pPr>
+            <a:r>
+              <a:t>Global state management without prop-drilling, culminating in a Multi-Theme Task Tracker.</a:t>
             </a:r>
           </a:p>
         </p:txBody>
@@ -3352,7 +3937,7 @@
         </p:nvSpPr>
         <p:spPr>
           <a:xfrm>
-            <a:off x="731520" y="411480"/>
+            <a:off x="731520" y="365760"/>
             <a:ext cx="7315200" cy="320040"/>
           </a:xfrm>
           <a:prstGeom prst="rect">
@@ -3387,7 +3972,7 @@
         </p:nvSpPr>
         <p:spPr>
           <a:xfrm>
-            <a:off x="731520" y="731520"/>
+            <a:off x="731520" y="658368"/>
             <a:ext cx="10698480" cy="548640"/>
           </a:xfrm>
           <a:prstGeom prst="rect">
@@ -3402,14 +3987,14 @@
           <a:lstStyle/>
           <a:p>
             <a:pPr>
-              <a:defRPr sz="2400" b="1">
+              <a:defRPr sz="2300" b="1">
                 <a:solidFill>
                   <a:srgbClr val="FFFFFF"/>
                 </a:solidFill>
               </a:defRPr>
             </a:pPr>
             <a:r>
-              <a:t>Technical Curriculum &amp; Milestone Roadmap</a:t>
+              <a:t>Technical Curriculum &amp; 4-Day Milestone Roadmap</a:t>
             </a:r>
           </a:p>
         </p:txBody>
@@ -3422,7 +4007,7 @@
         </p:nvSpPr>
         <p:spPr>
           <a:xfrm>
-            <a:off x="731520" y="1325880"/>
+            <a:off x="731520" y="1234440"/>
             <a:ext cx="10728655" cy="13716"/>
           </a:xfrm>
           <a:prstGeom prst="rect">
@@ -3465,8 +4050,8 @@
         </p:nvSpPr>
         <p:spPr>
           <a:xfrm>
-            <a:off x="731520" y="1554480"/>
-            <a:ext cx="2560320" cy="4754880"/>
+            <a:off x="731520" y="1463040"/>
+            <a:ext cx="2560320" cy="4846320"/>
           </a:xfrm>
           <a:prstGeom prst="roundRect">
             <a:avLst/>
@@ -3510,8 +4095,8 @@
         </p:nvSpPr>
         <p:spPr>
           <a:xfrm>
-            <a:off x="868680" y="1691640"/>
-            <a:ext cx="2286000" cy="4389120"/>
+            <a:off x="868680" y="1600200"/>
+            <a:ext cx="2286000" cy="4480560"/>
           </a:xfrm>
           <a:prstGeom prst="rect">
             <a:avLst/>
@@ -3653,8 +4238,8 @@
         </p:nvSpPr>
         <p:spPr>
           <a:xfrm>
-            <a:off x="3456432" y="1554480"/>
-            <a:ext cx="2560320" cy="4754880"/>
+            <a:off x="3456432" y="1463040"/>
+            <a:ext cx="2560320" cy="4846320"/>
           </a:xfrm>
           <a:prstGeom prst="roundRect">
             <a:avLst/>
@@ -3698,8 +4283,8 @@
         </p:nvSpPr>
         <p:spPr>
           <a:xfrm>
-            <a:off x="3593592" y="1691640"/>
-            <a:ext cx="2286000" cy="4389120"/>
+            <a:off x="3593592" y="1600200"/>
+            <a:ext cx="2286000" cy="4480560"/>
           </a:xfrm>
           <a:prstGeom prst="rect">
             <a:avLst/>
@@ -3841,8 +4426,8 @@
         </p:nvSpPr>
         <p:spPr>
           <a:xfrm>
-            <a:off x="6181344" y="1554480"/>
-            <a:ext cx="2560320" cy="4754880"/>
+            <a:off x="6181344" y="1463040"/>
+            <a:ext cx="2560320" cy="4846320"/>
           </a:xfrm>
           <a:prstGeom prst="roundRect">
             <a:avLst/>
@@ -3886,8 +4471,8 @@
         </p:nvSpPr>
         <p:spPr>
           <a:xfrm>
-            <a:off x="6318504" y="1691640"/>
-            <a:ext cx="2286000" cy="4389120"/>
+            <a:off x="6318504" y="1600200"/>
+            <a:ext cx="2286000" cy="4480560"/>
           </a:xfrm>
           <a:prstGeom prst="rect">
             <a:avLst/>
@@ -4029,8 +4614,8 @@
         </p:nvSpPr>
         <p:spPr>
           <a:xfrm>
-            <a:off x="8906256" y="1554480"/>
-            <a:ext cx="2560320" cy="4754880"/>
+            <a:off x="8906256" y="1463040"/>
+            <a:ext cx="2560320" cy="4846320"/>
           </a:xfrm>
           <a:prstGeom prst="roundRect">
             <a:avLst/>
@@ -4074,8 +4659,8 @@
         </p:nvSpPr>
         <p:spPr>
           <a:xfrm>
-            <a:off x="9043416" y="1691640"/>
-            <a:ext cx="2286000" cy="4389120"/>
+            <a:off x="9043416" y="1600200"/>
+            <a:ext cx="2286000" cy="4480560"/>
           </a:xfrm>
           <a:prstGeom prst="rect">
             <a:avLst/>
@@ -4278,7 +4863,7 @@
         </p:nvSpPr>
         <p:spPr>
           <a:xfrm>
-            <a:off x="731520" y="411480"/>
+            <a:off x="731520" y="365760"/>
             <a:ext cx="7315200" cy="320040"/>
           </a:xfrm>
           <a:prstGeom prst="rect">
@@ -4313,7 +4898,7 @@
         </p:nvSpPr>
         <p:spPr>
           <a:xfrm>
-            <a:off x="731520" y="731520"/>
+            <a:off x="731520" y="658368"/>
             <a:ext cx="10698480" cy="548640"/>
           </a:xfrm>
           <a:prstGeom prst="rect">
@@ -4328,14 +4913,14 @@
           <a:lstStyle/>
           <a:p>
             <a:pPr>
-              <a:defRPr sz="2400" b="1">
+              <a:defRPr sz="2300" b="1">
                 <a:solidFill>
                   <a:srgbClr val="FFFFFF"/>
                 </a:solidFill>
               </a:defRPr>
             </a:pPr>
             <a:r>
-              <a:t>Modern Web Standards &amp; Team Git Workflows</a:t>
+              <a:t>Day 01: Modern Web Standards &amp; Team Git Workflows</a:t>
             </a:r>
           </a:p>
         </p:txBody>
@@ -4348,7 +4933,7 @@
         </p:nvSpPr>
         <p:spPr>
           <a:xfrm>
-            <a:off x="731520" y="1325880"/>
+            <a:off x="731520" y="1234440"/>
             <a:ext cx="10728655" cy="13716"/>
           </a:xfrm>
           <a:prstGeom prst="rect">
@@ -4391,8 +4976,8 @@
         </p:nvSpPr>
         <p:spPr>
           <a:xfrm>
-            <a:off x="731520" y="1554480"/>
-            <a:ext cx="5212080" cy="4754880"/>
+            <a:off x="731520" y="1463040"/>
+            <a:ext cx="5212080" cy="4846320"/>
           </a:xfrm>
           <a:prstGeom prst="roundRect">
             <a:avLst/>
@@ -4436,8 +5021,8 @@
         </p:nvSpPr>
         <p:spPr>
           <a:xfrm>
-            <a:off x="1005840" y="1737360"/>
-            <a:ext cx="4663440" cy="4297680"/>
+            <a:off x="1005840" y="1645920"/>
+            <a:ext cx="4663440" cy="4389120"/>
           </a:xfrm>
           <a:prstGeom prst="rect">
             <a:avLst/>
@@ -4452,16 +5037,16 @@
           <a:p>
             <a:pPr>
               <a:spcAft>
-                <a:spcPts val="1600"/>
-              </a:spcAft>
-              <a:defRPr sz="1800" b="1">
+                <a:spcPts val="1400"/>
+              </a:spcAft>
+              <a:defRPr sz="1700" b="1">
                 <a:solidFill>
                   <a:srgbClr val="FFFFFF"/>
                 </a:solidFill>
               </a:defRPr>
             </a:pPr>
             <a:r>
-              <a:t>Core Engineering Principles</a:t>
+              <a:t>Architectural Decisions &amp; Standards</a:t>
             </a:r>
           </a:p>
           <a:p>
@@ -4469,29 +5054,29 @@
               <a:spcAft>
                 <a:spcPts val="200"/>
               </a:spcAft>
-              <a:defRPr sz="1250" b="1">
+              <a:defRPr sz="1200" b="1">
                 <a:solidFill>
                   <a:srgbClr val="FCD34D"/>
                 </a:solidFill>
               </a:defRPr>
             </a:pPr>
             <a:r>
-              <a:t>✔  Semantic HTML5 Hierarchy</a:t>
-            </a:r>
-          </a:p>
-          <a:p>
-            <a:pPr>
-              <a:spcAft>
-                <a:spcPts val="1200"/>
-              </a:spcAft>
-              <a:defRPr sz="1100">
+              <a:t>✔  Semantic HTML5 Hierarchy (index.html: L30-L240)</a:t>
+            </a:r>
+          </a:p>
+          <a:p>
+            <a:pPr>
+              <a:spcAft>
+                <a:spcPts val="1000"/>
+              </a:spcAft>
+              <a:defRPr sz="1050">
                 <a:solidFill>
                   <a:srgbClr val="E4E4E7"/>
                 </a:solidFill>
               </a:defRPr>
             </a:pPr>
             <a:r>
-              <a:t>Structure with &lt;header&gt;, &lt;nav&gt;, &lt;main&gt;, &lt;article&gt;, and &lt;footer&gt; to eliminate unindexed div soup, maximizing SEO visibility and accessibility.</a:t>
+              <a:t>Utilized &lt;header&gt;, &lt;nav&gt;, &lt;main&gt;, &lt;aside&gt;, &lt;article&gt;, and &lt;footer&gt;. Replaced generic div soup to maximize Google SEO and screen reader accessibility.</a:t>
             </a:r>
           </a:p>
           <a:p>
@@ -4499,29 +5084,29 @@
               <a:spcAft>
                 <a:spcPts val="200"/>
               </a:spcAft>
-              <a:defRPr sz="1250" b="1">
+              <a:defRPr sz="1200" b="1">
                 <a:solidFill>
                   <a:srgbClr val="FCD34D"/>
                 </a:solidFill>
               </a:defRPr>
             </a:pPr>
             <a:r>
-              <a:t>✔  CSS Layout Engines (Flexbox vs Grid)</a:t>
-            </a:r>
-          </a:p>
-          <a:p>
-            <a:pPr>
-              <a:spcAft>
-                <a:spcPts val="1200"/>
-              </a:spcAft>
-              <a:defRPr sz="1100">
+              <a:t>✔  1D Flexbox vs 2D CSS Grid (styles.css)</a:t>
+            </a:r>
+          </a:p>
+          <a:p>
+            <a:pPr>
+              <a:spcAft>
+                <a:spcPts val="1000"/>
+              </a:spcAft>
+              <a:defRPr sz="1050">
                 <a:solidFill>
                   <a:srgbClr val="E4E4E7"/>
                 </a:solidFill>
               </a:defRPr>
             </a:pPr>
             <a:r>
-              <a:t>Flexbox for 1D single-axis alignment (navbars, cards) and CSS Grid for 2D auto-responsive dashboard matrices.</a:t>
+              <a:t>Flexbox aligns 1D axes (.header-container, .quick-tags) with justify-content: space-between. CSS Grid powers 2D dashboard layouts.</a:t>
             </a:r>
           </a:p>
           <a:p>
@@ -4529,29 +5114,29 @@
               <a:spcAft>
                 <a:spcPts val="200"/>
               </a:spcAft>
-              <a:defRPr sz="1250" b="1">
+              <a:defRPr sz="1200" b="1">
                 <a:solidFill>
                   <a:srgbClr val="FCD34D"/>
                 </a:solidFill>
               </a:defRPr>
             </a:pPr>
             <a:r>
-              <a:t>✔  Feature-Branching Strategy</a:t>
-            </a:r>
-          </a:p>
-          <a:p>
-            <a:pPr>
-              <a:spcAft>
-                <a:spcPts val="1200"/>
-              </a:spcAft>
-              <a:defRPr sz="1100">
+              <a:t>✔  The Golden Responsive Grid Formula</a:t>
+            </a:r>
+          </a:p>
+          <a:p>
+            <a:pPr>
+              <a:spcAft>
+                <a:spcPts val="1000"/>
+              </a:spcAft>
+              <a:defRPr sz="1050">
                 <a:solidFill>
                   <a:srgbClr val="E4E4E7"/>
                 </a:solidFill>
               </a:defRPr>
             </a:pPr>
             <a:r>
-              <a:t>Production main branch stays locked and stable. Features are isolated in feature/task-name branches and merged via Pull Requests.</a:t>
+              <a:t>grid-template-columns: repeat(auto-fit, minmax(280px, 1fr)) creates automatic multi-column responsiveness without writing CSS media queries!</a:t>
             </a:r>
           </a:p>
           <a:p>
@@ -4559,29 +5144,29 @@
               <a:spcAft>
                 <a:spcPts val="200"/>
               </a:spcAft>
-              <a:defRPr sz="1250" b="1">
+              <a:defRPr sz="1200" b="1">
                 <a:solidFill>
                   <a:srgbClr val="FCD34D"/>
                 </a:solidFill>
               </a:defRPr>
             </a:pPr>
             <a:r>
-              <a:t>✔  Conventional Commit Standards</a:t>
-            </a:r>
-          </a:p>
-          <a:p>
-            <a:pPr>
-              <a:spcAft>
-                <a:spcPts val="1200"/>
-              </a:spcAft>
-              <a:defRPr sz="1100">
+              <a:t>✔  Professional Feature-Branching Git Workflow</a:t>
+            </a:r>
+          </a:p>
+          <a:p>
+            <a:pPr>
+              <a:spcAft>
+                <a:spcPts val="1000"/>
+              </a:spcAft>
+              <a:defRPr sz="1050">
                 <a:solidFill>
                   <a:srgbClr val="E4E4E7"/>
                 </a:solidFill>
               </a:defRPr>
             </a:pPr>
             <a:r>
-              <a:t>Enforces standardized commit tags (feat:, fix:, docs:, refactor:) for clear, automated changelogs.</a:t>
+              <a:t>All changes isolated in feature branches (git checkout -b) with Conventional Commits (feat:, fix:, docs:) before merging via PRs.</a:t>
             </a:r>
           </a:p>
         </p:txBody>
@@ -4594,14 +5179,14 @@
         </p:nvSpPr>
         <p:spPr>
           <a:xfrm>
-            <a:off x="6217920" y="1554480"/>
-            <a:ext cx="5242255" cy="4754880"/>
+            <a:off x="6217920" y="1463040"/>
+            <a:ext cx="5242255" cy="4846320"/>
           </a:xfrm>
           <a:prstGeom prst="roundRect">
             <a:avLst/>
           </a:prstGeom>
           <a:solidFill>
-            <a:srgbClr val="1A1A1E"/>
+            <a:srgbClr val="0F0F12"/>
           </a:solidFill>
           <a:ln w="12700">
             <a:solidFill>
@@ -4631,30 +5216,123 @@
           </a:p>
         </p:txBody>
       </p:sp>
-      <p:pic>
-        <p:nvPicPr>
-          <p:cNvPr id="9" name="Picture 8" descr="git_branching_diagram.png"/>
-          <p:cNvPicPr>
-            <a:picLocks noChangeAspect="1"/>
-          </p:cNvPicPr>
+      <p:sp>
+        <p:nvSpPr>
+          <p:cNvPr id="9" name="TextBox 8"/>
+          <p:cNvSpPr txBox="1"/>
           <p:nvPr/>
-        </p:nvPicPr>
-        <p:blipFill>
-          <a:blip r:embed="rId2"/>
-          <a:stretch>
-            <a:fillRect/>
-          </a:stretch>
-        </p:blipFill>
-        <p:spPr>
-          <a:xfrm>
-            <a:off x="6355080" y="1691640"/>
-            <a:ext cx="4967935" cy="4036447"/>
+        </p:nvSpPr>
+        <p:spPr>
+          <a:xfrm>
+            <a:off x="6400800" y="1645920"/>
+            <a:ext cx="4876495" cy="4389120"/>
           </a:xfrm>
           <a:prstGeom prst="rect">
             <a:avLst/>
           </a:prstGeom>
-        </p:spPr>
-      </p:pic>
+          <a:noFill/>
+        </p:spPr>
+        <p:txBody>
+          <a:bodyPr wrap="square" lIns="0" tIns="0" rIns="0" bIns="0">
+            <a:spAutoFit/>
+          </a:bodyPr>
+          <a:lstStyle/>
+          <a:p>
+            <a:pPr>
+              <a:spcAft>
+                <a:spcPts val="1000"/>
+              </a:spcAft>
+              <a:defRPr sz="1300" b="1">
+                <a:solidFill>
+                  <a:srgbClr val="F59E0B"/>
+                </a:solidFill>
+              </a:defRPr>
+            </a:pPr>
+            <a:r>
+              <a:t>📄 Production Snippet: HTML5, CSS Grid &amp; Git</a:t>
+            </a:r>
+          </a:p>
+          <a:p>
+            <a:pPr>
+              <a:defRPr sz="1000">
+                <a:solidFill>
+                  <a:srgbClr val="34D399"/>
+                </a:solidFill>
+                <a:latin typeface="Consolas"/>
+              </a:defRPr>
+            </a:pPr>
+            <a:r>
+              <a:t>/* 1. CSS GRID: Golden Auto-Responsive Formula */</a:t>
+            </a:r>
+            <a:br/>
+            <a:r>
+              <a:t>.repos-grid {</a:t>
+            </a:r>
+            <a:br/>
+            <a:r>
+              <a:t>  display: grid;</a:t>
+            </a:r>
+            <a:br/>
+            <a:r>
+              <a:t>  grid-template-columns: repeat(auto-fit, minmax(280px, 1fr));</a:t>
+            </a:r>
+            <a:br/>
+            <a:r>
+              <a:t>  gap: 1.5rem;</a:t>
+            </a:r>
+            <a:br/>
+            <a:r>
+              <a:t>}</a:t>
+            </a:r>
+            <a:br/>
+            <a:br/>
+            <a:r>
+              <a:t>/* 2. FLEXBOX: 1D Single-Axis Navbar */</a:t>
+            </a:r>
+            <a:br/>
+            <a:r>
+              <a:t>.header-container {</a:t>
+            </a:r>
+            <a:br/>
+            <a:r>
+              <a:t>  display: flex;</a:t>
+            </a:r>
+            <a:br/>
+            <a:r>
+              <a:t>  justify-content: space-between; /* Space logo &amp; tabs */</a:t>
+            </a:r>
+            <a:br/>
+            <a:r>
+              <a:t>  align-items: center;            /* Vertical center */</a:t>
+            </a:r>
+            <a:br/>
+            <a:r>
+              <a:t>}</a:t>
+            </a:r>
+            <a:br/>
+            <a:br/>
+            <a:r>
+              <a:t># 3. Professional Git Team Workflow</a:t>
+            </a:r>
+            <a:br/>
+            <a:r>
+              <a:t>$ git checkout -b feature/dashboard-ui</a:t>
+            </a:r>
+            <a:br/>
+            <a:r>
+              <a:t>$ git add index.html styles.css</a:t>
+            </a:r>
+            <a:br/>
+            <a:r>
+              <a:t>$ git commit -m "feat: build semantic dashboard"</a:t>
+            </a:r>
+            <a:br/>
+            <a:r>
+              <a:t>$ git push -u origin feature/dashboard-ui</a:t>
+            </a:r>
+          </a:p>
+        </p:txBody>
+      </p:sp>
     </p:spTree>
   </p:cSld>
   <p:clrMapOvr>
@@ -4724,7 +5402,7 @@
         </p:nvSpPr>
         <p:spPr>
           <a:xfrm>
-            <a:off x="731520" y="411480"/>
+            <a:off x="731520" y="365760"/>
             <a:ext cx="7315200" cy="320040"/>
           </a:xfrm>
           <a:prstGeom prst="rect">
@@ -4746,7 +5424,7 @@
               </a:defRPr>
             </a:pPr>
             <a:r>
-              <a:t>DAY 02 CORE JS</a:t>
+              <a:t>DAY 02 CORE ENGINE</a:t>
             </a:r>
           </a:p>
         </p:txBody>
@@ -4759,7 +5437,7 @@
         </p:nvSpPr>
         <p:spPr>
           <a:xfrm>
-            <a:off x="731520" y="731520"/>
+            <a:off x="731520" y="658368"/>
             <a:ext cx="10698480" cy="548640"/>
           </a:xfrm>
           <a:prstGeom prst="rect">
@@ -4774,14 +5452,14 @@
           <a:lstStyle/>
           <a:p>
             <a:pPr>
-              <a:defRPr sz="2400" b="1">
+              <a:defRPr sz="2300" b="1">
                 <a:solidFill>
                   <a:srgbClr val="FFFFFF"/>
                 </a:solidFill>
               </a:defRPr>
             </a:pPr>
             <a:r>
-              <a:t>Advanced JavaScript &amp; Functional Data Pipelines</a:t>
+              <a:t>Day 02: Advanced JS Scope &amp; Event Loop Engine</a:t>
             </a:r>
           </a:p>
         </p:txBody>
@@ -4794,7 +5472,7 @@
         </p:nvSpPr>
         <p:spPr>
           <a:xfrm>
-            <a:off x="731520" y="1325880"/>
+            <a:off x="731520" y="1234440"/>
             <a:ext cx="10728655" cy="13716"/>
           </a:xfrm>
           <a:prstGeom prst="rect">
@@ -4837,8 +5515,8 @@
         </p:nvSpPr>
         <p:spPr>
           <a:xfrm>
-            <a:off x="731520" y="1554480"/>
-            <a:ext cx="5212080" cy="4754880"/>
+            <a:off x="731520" y="1463040"/>
+            <a:ext cx="5212080" cy="4846320"/>
           </a:xfrm>
           <a:prstGeom prst="roundRect">
             <a:avLst/>
@@ -4882,8 +5560,8 @@
         </p:nvSpPr>
         <p:spPr>
           <a:xfrm>
-            <a:off x="1005840" y="1737360"/>
-            <a:ext cx="4663440" cy="4297680"/>
+            <a:off x="1005840" y="1645920"/>
+            <a:ext cx="4663440" cy="4389120"/>
           </a:xfrm>
           <a:prstGeom prst="rect">
             <a:avLst/>
@@ -4898,16 +5576,16 @@
           <a:p>
             <a:pPr>
               <a:spcAft>
-                <a:spcPts val="1600"/>
-              </a:spcAft>
-              <a:defRPr sz="1800" b="1">
+                <a:spcPts val="1400"/>
+              </a:spcAft>
+              <a:defRPr sz="1700" b="1">
                 <a:solidFill>
                   <a:srgbClr val="FFFFFF"/>
                 </a:solidFill>
               </a:defRPr>
             </a:pPr>
             <a:r>
-              <a:t>ES6+ Architecture &amp; Scope</a:t>
+              <a:t>Memory, Scope &amp; Engine Concurrency</a:t>
             </a:r>
           </a:p>
           <a:p>
@@ -4915,29 +5593,29 @@
               <a:spcAft>
                 <a:spcPts val="200"/>
               </a:spcAft>
-              <a:defRPr sz="1250" b="1">
+              <a:defRPr sz="1200" b="1">
                 <a:solidFill>
                   <a:srgbClr val="FCD34D"/>
                 </a:solidFill>
               </a:defRPr>
             </a:pPr>
             <a:r>
-              <a:t>⚡  Block Scope (const / let)</a:t>
-            </a:r>
-          </a:p>
-          <a:p>
-            <a:pPr>
-              <a:spcAft>
-                <a:spcPts val="1400"/>
-              </a:spcAft>
-              <a:defRPr sz="1100">
+              <a:t>⚡  Block Scope &amp; TDZ (const vs let vs var)</a:t>
+            </a:r>
+          </a:p>
+          <a:p>
+            <a:pPr>
+              <a:spcAft>
+                <a:spcPts val="1000"/>
+              </a:spcAft>
+              <a:defRPr sz="1050">
                 <a:solidFill>
                   <a:srgbClr val="E4E4E7"/>
                 </a:solidFill>
               </a:defRPr>
             </a:pPr>
             <a:r>
-              <a:t>Eliminated var hoisting hazards and scope leakage. Using const by default guarantees immutable variable bindings.</a:t>
+              <a:t>const by default prevents identifier rebinding. Eliminated var scope-leakage bugs and hoisting hazards via Temporal Dead Zone (TDZ).</a:t>
             </a:r>
           </a:p>
           <a:p>
@@ -4945,29 +5623,29 @@
               <a:spcAft>
                 <a:spcPts val="200"/>
               </a:spcAft>
-              <a:defRPr sz="1250" b="1">
+              <a:defRPr sz="1200" b="1">
                 <a:solidFill>
                   <a:srgbClr val="FCD34D"/>
                 </a:solidFill>
               </a:defRPr>
             </a:pPr>
             <a:r>
-              <a:t>⚡  Destructuring &amp; Spread Operator (...)</a:t>
-            </a:r>
-          </a:p>
-          <a:p>
-            <a:pPr>
-              <a:spcAft>
-                <a:spcPts val="1400"/>
-              </a:spcAft>
-              <a:defRPr sz="1100">
+              <a:t>⚡  Single-Threaded Call Stack (LIFO)</a:t>
+            </a:r>
+          </a:p>
+          <a:p>
+            <a:pPr>
+              <a:spcAft>
+                <a:spcPts val="1000"/>
+              </a:spcAft>
+              <a:defRPr sz="1050">
                 <a:solidFill>
                   <a:srgbClr val="E4E4E7"/>
                 </a:solidFill>
               </a:defRPr>
             </a:pPr>
             <a:r>
-              <a:t>Clean object/array unpacking and shallow cloning, forming the foundation for immutable React state updates.</a:t>
+              <a:t>V8 executes synchronous JavaScript code sequentially. Blocking operations are offloaded to background Web APIs / Libuv.</a:t>
             </a:r>
           </a:p>
           <a:p>
@@ -4975,29 +5653,59 @@
               <a:spcAft>
                 <a:spcPts val="200"/>
               </a:spcAft>
-              <a:defRPr sz="1250" b="1">
+              <a:defRPr sz="1200" b="1">
                 <a:solidFill>
                   <a:srgbClr val="FCD34D"/>
                 </a:solidFill>
               </a:defRPr>
             </a:pPr>
             <a:r>
-              <a:t>⚡  Nullish Coalescing (??) &amp; Optional Chaining (?.)</a:t>
-            </a:r>
-          </a:p>
-          <a:p>
-            <a:pPr>
-              <a:spcAft>
-                <a:spcPts val="1400"/>
-              </a:spcAft>
-              <a:defRPr sz="1100">
+              <a:t>⚡  Microtask Queue (VIP Priority)</a:t>
+            </a:r>
+          </a:p>
+          <a:p>
+            <a:pPr>
+              <a:spcAft>
+                <a:spcPts val="1000"/>
+              </a:spcAft>
+              <a:defRPr sz="1050">
                 <a:solidFill>
                   <a:srgbClr val="E4E4E7"/>
                 </a:solidFill>
               </a:defRPr>
             </a:pPr>
             <a:r>
-              <a:t>Safely navigates deep nested API objects without throwing uncaught runtime errors.</a:t>
+              <a:t>Promises (.then, async/await) enter the Microtask queue, executing immediately when Call Stack empties before any Macrotask.</a:t>
+            </a:r>
+          </a:p>
+          <a:p>
+            <a:pPr>
+              <a:spcAft>
+                <a:spcPts val="200"/>
+              </a:spcAft>
+              <a:defRPr sz="1200" b="1">
+                <a:solidFill>
+                  <a:srgbClr val="FCD34D"/>
+                </a:solidFill>
+              </a:defRPr>
+            </a:pPr>
+            <a:r>
+              <a:t>⚡  Macrotask Queue (setTimeout)</a:t>
+            </a:r>
+          </a:p>
+          <a:p>
+            <a:pPr>
+              <a:spcAft>
+                <a:spcPts val="1000"/>
+              </a:spcAft>
+              <a:defRPr sz="1050">
+                <a:solidFill>
+                  <a:srgbClr val="E4E4E7"/>
+                </a:solidFill>
+              </a:defRPr>
+            </a:pPr>
+            <a:r>
+              <a:t>Timers execute strictly after all microtasks finish. Used in Toast notification auto-dismissal.</a:t>
             </a:r>
           </a:p>
         </p:txBody>
@@ -5010,8 +5718,8 @@
         </p:nvSpPr>
         <p:spPr>
           <a:xfrm>
-            <a:off x="6217920" y="1554480"/>
-            <a:ext cx="5242255" cy="4754880"/>
+            <a:off x="6217920" y="1463040"/>
+            <a:ext cx="5242255" cy="4846320"/>
           </a:xfrm>
           <a:prstGeom prst="roundRect">
             <a:avLst/>
@@ -5047,138 +5755,30 @@
           </a:p>
         </p:txBody>
       </p:sp>
-      <p:sp>
-        <p:nvSpPr>
-          <p:cNvPr id="9" name="TextBox 8"/>
-          <p:cNvSpPr txBox="1"/>
+      <p:pic>
+        <p:nvPicPr>
+          <p:cNvPr id="9" name="Picture 8" descr="event_loop_diagram.png"/>
+          <p:cNvPicPr>
+            <a:picLocks noChangeAspect="1"/>
+          </p:cNvPicPr>
           <p:nvPr/>
-        </p:nvSpPr>
-        <p:spPr>
-          <a:xfrm>
-            <a:off x="6492240" y="1737360"/>
-            <a:ext cx="4663440" cy="4297680"/>
+        </p:nvPicPr>
+        <p:blipFill>
+          <a:blip r:embed="rId2"/>
+          <a:stretch>
+            <a:fillRect/>
+          </a:stretch>
+        </p:blipFill>
+        <p:spPr>
+          <a:xfrm>
+            <a:off x="6355080" y="1600200"/>
+            <a:ext cx="4967935" cy="4036447"/>
           </a:xfrm>
           <a:prstGeom prst="rect">
             <a:avLst/>
           </a:prstGeom>
-          <a:noFill/>
-        </p:spPr>
-        <p:txBody>
-          <a:bodyPr wrap="square" lIns="0" tIns="0" rIns="0" bIns="0">
-            <a:spAutoFit/>
-          </a:bodyPr>
-          <a:lstStyle/>
-          <a:p>
-            <a:pPr>
-              <a:spcAft>
-                <a:spcPts val="1600"/>
-              </a:spcAft>
-              <a:defRPr sz="1800" b="1">
-                <a:solidFill>
-                  <a:srgbClr val="FFFFFF"/>
-                </a:solidFill>
-              </a:defRPr>
-            </a:pPr>
-            <a:r>
-              <a:t>Higher-Order Array Methods</a:t>
-            </a:r>
-          </a:p>
-          <a:p>
-            <a:pPr>
-              <a:spcAft>
-                <a:spcPts val="200"/>
-              </a:spcAft>
-              <a:defRPr sz="1250" b="1">
-                <a:solidFill>
-                  <a:srgbClr val="F59E0B"/>
-                </a:solidFill>
-              </a:defRPr>
-            </a:pPr>
-            <a:r>
-              <a:t>📊  .map() — 1-to-1 UI Transformation</a:t>
-            </a:r>
-          </a:p>
-          <a:p>
-            <a:pPr>
-              <a:spcAft>
-                <a:spcPts val="1400"/>
-              </a:spcAft>
-              <a:defRPr sz="1100">
-                <a:solidFill>
-                  <a:srgbClr val="E4E4E7"/>
-                </a:solidFill>
-              </a:defRPr>
-            </a:pPr>
-            <a:r>
-              <a:t>Transforms raw backend API payloads into structured UI presentation elements without mutating source arrays.</a:t>
-            </a:r>
-          </a:p>
-          <a:p>
-            <a:pPr>
-              <a:spcAft>
-                <a:spcPts val="200"/>
-              </a:spcAft>
-              <a:defRPr sz="1250" b="1">
-                <a:solidFill>
-                  <a:srgbClr val="F59E0B"/>
-                </a:solidFill>
-              </a:defRPr>
-            </a:pPr>
-            <a:r>
-              <a:t>📊  .filter() — Boolean Data Selection</a:t>
-            </a:r>
-          </a:p>
-          <a:p>
-            <a:pPr>
-              <a:spcAft>
-                <a:spcPts val="1400"/>
-              </a:spcAft>
-              <a:defRPr sz="1100">
-                <a:solidFill>
-                  <a:srgbClr val="E4E4E7"/>
-                </a:solidFill>
-              </a:defRPr>
-            </a:pPr>
-            <a:r>
-              <a:t>Extracts active, non-forked repositories matching user filter criteria.</a:t>
-            </a:r>
-          </a:p>
-          <a:p>
-            <a:pPr>
-              <a:spcAft>
-                <a:spcPts val="200"/>
-              </a:spcAft>
-              <a:defRPr sz="1250" b="1">
-                <a:solidFill>
-                  <a:srgbClr val="F59E0B"/>
-                </a:solidFill>
-              </a:defRPr>
-            </a:pPr>
-            <a:r>
-              <a:t>📊  .reduce() — Single-Pass Analytical Aggregation</a:t>
-            </a:r>
-          </a:p>
-          <a:p>
-            <a:pPr>
-              <a:spcAft>
-                <a:spcPts val="1400"/>
-              </a:spcAft>
-              <a:defRPr sz="1100">
-                <a:solidFill>
-                  <a:srgbClr val="E4E4E7"/>
-                </a:solidFill>
-              </a:defRPr>
-            </a:pPr>
-            <a:r>
-              <a:t>Computes total stars, fork count, and primary language in 1 single pass:</a:t>
-            </a:r>
-            <a:br/>
-            <a:r>
-              <a:t>const totalStars = repos.reduce((sum, r) =&gt; sum + r.stargazers_count, 0);</a:t>
-            </a:r>
-          </a:p>
-        </p:txBody>
-      </p:sp>
+        </p:spPr>
+      </p:pic>
     </p:spTree>
   </p:cSld>
   <p:clrMapOvr>
@@ -5248,7 +5848,7 @@
         </p:nvSpPr>
         <p:spPr>
           <a:xfrm>
-            <a:off x="731520" y="411480"/>
+            <a:off x="731520" y="365760"/>
             <a:ext cx="7315200" cy="320040"/>
           </a:xfrm>
           <a:prstGeom prst="rect">
@@ -5270,7 +5870,7 @@
               </a:defRPr>
             </a:pPr>
             <a:r>
-              <a:t>DAY 02 DEEP DIVE</a:t>
+              <a:t>APP ARCHITECTURE</a:t>
             </a:r>
           </a:p>
         </p:txBody>
@@ -5283,7 +5883,7 @@
         </p:nvSpPr>
         <p:spPr>
           <a:xfrm>
-            <a:off x="731520" y="731520"/>
+            <a:off x="731520" y="658368"/>
             <a:ext cx="10698480" cy="548640"/>
           </a:xfrm>
           <a:prstGeom prst="rect">
@@ -5298,14 +5898,14 @@
           <a:lstStyle/>
           <a:p>
             <a:pPr>
-              <a:defRPr sz="2400" b="1">
+              <a:defRPr sz="2300" b="1">
                 <a:solidFill>
                   <a:srgbClr val="FFFFFF"/>
                 </a:solidFill>
               </a:defRPr>
             </a:pPr>
             <a:r>
-              <a:t>JavaScript Event Loop &amp; Asynchronous Architecture</a:t>
+              <a:t>Mini-Project: Parallel API Fetching &amp; Caching</a:t>
             </a:r>
           </a:p>
         </p:txBody>
@@ -5318,7 +5918,7 @@
         </p:nvSpPr>
         <p:spPr>
           <a:xfrm>
-            <a:off x="731520" y="1325880"/>
+            <a:off x="731520" y="1234440"/>
             <a:ext cx="10728655" cy="13716"/>
           </a:xfrm>
           <a:prstGeom prst="rect">
@@ -5361,8 +5961,8 @@
         </p:nvSpPr>
         <p:spPr>
           <a:xfrm>
-            <a:off x="731520" y="1554480"/>
-            <a:ext cx="5212080" cy="4754880"/>
+            <a:off x="731520" y="1463040"/>
+            <a:ext cx="5212080" cy="4846320"/>
           </a:xfrm>
           <a:prstGeom prst="roundRect">
             <a:avLst/>
@@ -5406,8 +6006,8 @@
         </p:nvSpPr>
         <p:spPr>
           <a:xfrm>
-            <a:off x="1005840" y="1737360"/>
-            <a:ext cx="4663440" cy="4297680"/>
+            <a:off x="1005840" y="1645920"/>
+            <a:ext cx="4663440" cy="4389120"/>
           </a:xfrm>
           <a:prstGeom prst="rect">
             <a:avLst/>
@@ -5422,16 +6022,16 @@
           <a:p>
             <a:pPr>
               <a:spcAft>
-                <a:spcPts val="1600"/>
-              </a:spcAft>
-              <a:defRPr sz="1800" b="1">
+                <a:spcPts val="1400"/>
+              </a:spcAft>
+              <a:defRPr sz="1700" b="1">
                 <a:solidFill>
                   <a:srgbClr val="FFFFFF"/>
                 </a:solidFill>
               </a:defRPr>
             </a:pPr>
             <a:r>
-              <a:t>Concurrency &amp; Execution Queues</a:t>
+              <a:t>Parallel Network Engine &amp; In-Memory Cache</a:t>
             </a:r>
           </a:p>
           <a:p>
@@ -5439,14 +6039,14 @@
               <a:spcAft>
                 <a:spcPts val="200"/>
               </a:spcAft>
-              <a:defRPr sz="1250" b="1">
+              <a:defRPr sz="1200" b="1">
                 <a:solidFill>
                   <a:srgbClr val="FCD34D"/>
                 </a:solidFill>
               </a:defRPr>
             </a:pPr>
             <a:r>
-              <a:t>🔄  1. Single-Threaded Call Stack</a:t>
+              <a:t>🚀  In-Memory Map Cache (app.js: L23, L166)</a:t>
             </a:r>
           </a:p>
           <a:p>
@@ -5454,14 +6054,14 @@
               <a:spcAft>
                 <a:spcPts val="1000"/>
               </a:spcAft>
-              <a:defRPr sz="1100">
+              <a:defRPr sz="1050">
                 <a:solidFill>
                   <a:srgbClr val="E4E4E7"/>
                 </a:solidFill>
               </a:defRPr>
             </a:pPr>
             <a:r>
-              <a:t>V8 executes synchronous functions line-by-line (LIFO). Long I/O tasks are delegated to Web APIs.</a:t>
+              <a:t>ES6 Private Field #searchCache = new Map(). Checks if user was already fetched; re-renders in 0ms without hitting GitHub rate limits.</a:t>
             </a:r>
           </a:p>
           <a:p>
@@ -5469,14 +6069,14 @@
               <a:spcAft>
                 <a:spcPts val="200"/>
               </a:spcAft>
-              <a:defRPr sz="1250" b="1">
+              <a:defRPr sz="1200" b="1">
                 <a:solidFill>
                   <a:srgbClr val="FCD34D"/>
                 </a:solidFill>
               </a:defRPr>
             </a:pPr>
             <a:r>
-              <a:t>🔄  2. Microtask Queue (VIP Priority)</a:t>
+              <a:t>🚀  Promise.all Concurrent Fetching (app.js: L181)</a:t>
             </a:r>
           </a:p>
           <a:p>
@@ -5484,14 +6084,14 @@
               <a:spcAft>
                 <a:spcPts val="1000"/>
               </a:spcAft>
-              <a:defRPr sz="1100">
+              <a:defRPr sz="1050">
                 <a:solidFill>
                   <a:srgbClr val="E4E4E7"/>
                 </a:solidFill>
               </a:defRPr>
             </a:pPr>
             <a:r>
-              <a:t>Promises (.then(), async/await) enter the microtask queue and execute immediately after the Call Stack clears.</a:t>
+              <a:t>Dispatches User Profile and Repositories endpoints simultaneously in parallel, cutting network latency by 50% compared to sequential awaits.</a:t>
             </a:r>
           </a:p>
           <a:p>
@@ -5499,14 +6099,14 @@
               <a:spcAft>
                 <a:spcPts val="200"/>
               </a:spcAft>
-              <a:defRPr sz="1250" b="1">
+              <a:defRPr sz="1200" b="1">
                 <a:solidFill>
                   <a:srgbClr val="FCD34D"/>
                 </a:solidFill>
               </a:defRPr>
             </a:pPr>
             <a:r>
-              <a:t>🔄  3. Macrotask Queue</a:t>
+              <a:t>🚀  Stream Decoding (app.js: L197)</a:t>
             </a:r>
           </a:p>
           <a:p>
@@ -5514,14 +6114,14 @@
               <a:spcAft>
                 <a:spcPts val="1000"/>
               </a:spcAft>
-              <a:defRPr sz="1100">
+              <a:defRPr sz="1050">
                 <a:solidFill>
                   <a:srgbClr val="E4E4E7"/>
                 </a:solidFill>
               </a:defRPr>
             </a:pPr>
             <a:r>
-              <a:t>Timer callbacks (setTimeout, setInterval) wait until all pending microtasks are completely drained.</a:t>
+              <a:t>await userRes.json() decodes the raw incoming HTTP stream into live JavaScript objects.</a:t>
             </a:r>
           </a:p>
           <a:p>
@@ -5529,14 +6129,14 @@
               <a:spcAft>
                 <a:spcPts val="200"/>
               </a:spcAft>
-              <a:defRPr sz="1250" b="1">
+              <a:defRPr sz="1200" b="1">
                 <a:solidFill>
                   <a:srgbClr val="FCD34D"/>
                 </a:solidFill>
               </a:defRPr>
             </a:pPr>
             <a:r>
-              <a:t>🔄  4. Concurrent Promise.all()</a:t>
+              <a:t>🚀  Try / Catch Error Boundaries (app.js: L211)</a:t>
             </a:r>
           </a:p>
           <a:p>
@@ -5544,14 +6144,14 @@
               <a:spcAft>
                 <a:spcPts val="1000"/>
               </a:spcAft>
-              <a:defRPr sz="1100">
+              <a:defRPr sz="1050">
                 <a:solidFill>
                   <a:srgbClr val="E4E4E7"/>
                 </a:solidFill>
               </a:defRPr>
             </a:pPr>
             <a:r>
-              <a:t>Dispatches User Profile and Repositories API requests in parallel, cutting network latency by 50%.</a:t>
+              <a:t>Catches network dropouts and displays friendly UI alerts without crashing the runtime application.</a:t>
             </a:r>
           </a:p>
         </p:txBody>
@@ -5564,14 +6164,14 @@
         </p:nvSpPr>
         <p:spPr>
           <a:xfrm>
-            <a:off x="6217920" y="1554480"/>
-            <a:ext cx="5242255" cy="4754880"/>
+            <a:off x="6217920" y="1463040"/>
+            <a:ext cx="5242255" cy="4846320"/>
           </a:xfrm>
           <a:prstGeom prst="roundRect">
             <a:avLst/>
           </a:prstGeom>
           <a:solidFill>
-            <a:srgbClr val="1A1A1E"/>
+            <a:srgbClr val="0F0F12"/>
           </a:solidFill>
           <a:ln w="12700">
             <a:solidFill>
@@ -5601,30 +6201,115 @@
           </a:p>
         </p:txBody>
       </p:sp>
-      <p:pic>
-        <p:nvPicPr>
-          <p:cNvPr id="9" name="Picture 8" descr="event_loop_diagram.png"/>
-          <p:cNvPicPr>
-            <a:picLocks noChangeAspect="1"/>
-          </p:cNvPicPr>
+      <p:sp>
+        <p:nvSpPr>
+          <p:cNvPr id="9" name="TextBox 8"/>
+          <p:cNvSpPr txBox="1"/>
           <p:nvPr/>
-        </p:nvPicPr>
-        <p:blipFill>
-          <a:blip r:embed="rId2"/>
-          <a:stretch>
-            <a:fillRect/>
-          </a:stretch>
-        </p:blipFill>
-        <p:spPr>
-          <a:xfrm>
-            <a:off x="6355080" y="1691640"/>
-            <a:ext cx="4967935" cy="4036447"/>
+        </p:nvSpPr>
+        <p:spPr>
+          <a:xfrm>
+            <a:off x="6400800" y="1645920"/>
+            <a:ext cx="4876495" cy="4389120"/>
           </a:xfrm>
           <a:prstGeom prst="rect">
             <a:avLst/>
           </a:prstGeom>
-        </p:spPr>
-      </p:pic>
+          <a:noFill/>
+        </p:spPr>
+        <p:txBody>
+          <a:bodyPr wrap="square" lIns="0" tIns="0" rIns="0" bIns="0">
+            <a:spAutoFit/>
+          </a:bodyPr>
+          <a:lstStyle/>
+          <a:p>
+            <a:pPr>
+              <a:spcAft>
+                <a:spcPts val="1000"/>
+              </a:spcAft>
+              <a:defRPr sz="1300" b="1">
+                <a:solidFill>
+                  <a:srgbClr val="F59E0B"/>
+                </a:solidFill>
+              </a:defRPr>
+            </a:pPr>
+            <a:r>
+              <a:t>📄 app.js: Lines 166–203 (Parallel Fetch &amp; Cache)</a:t>
+            </a:r>
+          </a:p>
+          <a:p>
+            <a:pPr>
+              <a:defRPr sz="950">
+                <a:solidFill>
+                  <a:srgbClr val="34D399"/>
+                </a:solidFill>
+                <a:latin typeface="Consolas"/>
+              </a:defRPr>
+            </a:pPr>
+            <a:r>
+              <a:t>// 1. Check In-Memory Map Cache (0ms Instant Load)</a:t>
+            </a:r>
+            <a:br/>
+            <a:r>
+              <a:t>if (this.#searchCache.has(cleanUsername)) {</a:t>
+            </a:r>
+            <a:br/>
+            <a:r>
+              <a:t>  const cached = this.#searchCache.get(cleanUsername);</a:t>
+            </a:r>
+            <a:br/>
+            <a:r>
+              <a:t>  this.renderProfileCard(cached.user, true);</a:t>
+            </a:r>
+            <a:br/>
+            <a:r>
+              <a:t>  return;</a:t>
+            </a:r>
+            <a:br/>
+            <a:r>
+              <a:t>}</a:t>
+            </a:r>
+            <a:br/>
+            <a:br/>
+            <a:r>
+              <a:t>// 2. Parallel API Dispatch via Promise.all()</a:t>
+            </a:r>
+            <a:br/>
+            <a:r>
+              <a:t>const [userRes, reposRes] = await Promise.all([</a:t>
+            </a:r>
+            <a:br/>
+            <a:r>
+              <a:t>  fetch(`https://api.github.com/users/${username}`),</a:t>
+            </a:r>
+            <a:br/>
+            <a:r>
+              <a:t>  fetch(`https://api.github.com/users/${username}/repos?per_page=100`)</a:t>
+            </a:r>
+            <a:br/>
+            <a:r>
+              <a:t>]);</a:t>
+            </a:r>
+            <a:br/>
+            <a:br/>
+            <a:r>
+              <a:t>// 3. Stream Parsing &amp; State Persistence</a:t>
+            </a:r>
+            <a:br/>
+            <a:r>
+              <a:t>const userData = await userRes.json();</a:t>
+            </a:r>
+            <a:br/>
+            <a:r>
+              <a:t>const reposData = reposRes.ok ? await reposRes.json() : [];</a:t>
+            </a:r>
+            <a:br/>
+            <a:r>
+              <a:t>this.#searchCache.set(cleanUsername, { user: userData, repos: reposData });</a:t>
+            </a:r>
+          </a:p>
+        </p:txBody>
+      </p:sp>
     </p:spTree>
   </p:cSld>
   <p:clrMapOvr>
@@ -5694,7 +6379,7 @@
         </p:nvSpPr>
         <p:spPr>
           <a:xfrm>
-            <a:off x="731520" y="411480"/>
+            <a:off x="731520" y="365760"/>
             <a:ext cx="7315200" cy="320040"/>
           </a:xfrm>
           <a:prstGeom prst="rect">
@@ -5716,7 +6401,7 @@
               </a:defRPr>
             </a:pPr>
             <a:r>
-              <a:t>DAY 03 DOM ARCHITECTURE</a:t>
+              <a:t>DATA PIPELINES</a:t>
             </a:r>
           </a:p>
         </p:txBody>
@@ -5729,7 +6414,7 @@
         </p:nvSpPr>
         <p:spPr>
           <a:xfrm>
-            <a:off x="731520" y="731520"/>
+            <a:off x="731520" y="658368"/>
             <a:ext cx="10698480" cy="548640"/>
           </a:xfrm>
           <a:prstGeom prst="rect">
@@ -5744,14 +6429,14 @@
           <a:lstStyle/>
           <a:p>
             <a:pPr>
-              <a:defRPr sz="2400" b="1">
+              <a:defRPr sz="2300" b="1">
                 <a:solidFill>
                   <a:srgbClr val="FFFFFF"/>
                 </a:solidFill>
               </a:defRPr>
             </a:pPr>
             <a:r>
-              <a:t>DOM Event Delegation &amp; State Persistence</a:t>
+              <a:t>Mini-Project: Single-Pass Analytics Engine</a:t>
             </a:r>
           </a:p>
         </p:txBody>
@@ -5764,7 +6449,7 @@
         </p:nvSpPr>
         <p:spPr>
           <a:xfrm>
-            <a:off x="731520" y="1325880"/>
+            <a:off x="731520" y="1234440"/>
             <a:ext cx="10728655" cy="13716"/>
           </a:xfrm>
           <a:prstGeom prst="rect">
@@ -5807,8 +6492,8 @@
         </p:nvSpPr>
         <p:spPr>
           <a:xfrm>
-            <a:off x="731520" y="1554480"/>
-            <a:ext cx="5212080" cy="4754880"/>
+            <a:off x="731520" y="1463040"/>
+            <a:ext cx="5212080" cy="4846320"/>
           </a:xfrm>
           <a:prstGeom prst="roundRect">
             <a:avLst/>
@@ -5852,8 +6537,8 @@
         </p:nvSpPr>
         <p:spPr>
           <a:xfrm>
-            <a:off x="1005840" y="1737360"/>
-            <a:ext cx="4663440" cy="4297680"/>
+            <a:off x="1005840" y="1645920"/>
+            <a:ext cx="4663440" cy="4389120"/>
           </a:xfrm>
           <a:prstGeom prst="rect">
             <a:avLst/>
@@ -5868,16 +6553,16 @@
           <a:p>
             <a:pPr>
               <a:spcAft>
-                <a:spcPts val="1600"/>
-              </a:spcAft>
-              <a:defRPr sz="1800" b="1">
+                <a:spcPts val="1400"/>
+              </a:spcAft>
+              <a:defRPr sz="1700" b="1">
                 <a:solidFill>
                   <a:srgbClr val="FFFFFF"/>
                 </a:solidFill>
               </a:defRPr>
             </a:pPr>
             <a:r>
-              <a:t>Memory Optimization &amp; Storage</a:t>
+              <a:t>Higher-Order Analytical Aggregation</a:t>
             </a:r>
           </a:p>
           <a:p>
@@ -5885,14 +6570,14 @@
               <a:spcAft>
                 <a:spcPts val="200"/>
               </a:spcAft>
-              <a:defRPr sz="1250" b="1">
+              <a:defRPr sz="1200" b="1">
                 <a:solidFill>
                   <a:srgbClr val="FCD34D"/>
                 </a:solidFill>
               </a:defRPr>
             </a:pPr>
             <a:r>
-              <a:t>🎯  Event Bubbling Mechanism</a:t>
+              <a:t>📊  Total Stars in 1-Pass (app.js: L228)</a:t>
             </a:r>
           </a:p>
           <a:p>
@@ -5900,14 +6585,14 @@
               <a:spcAft>
                 <a:spcPts val="1000"/>
               </a:spcAft>
-              <a:defRPr sz="1100">
+              <a:defRPr sz="1050">
                 <a:solidFill>
                   <a:srgbClr val="E4E4E7"/>
                 </a:solidFill>
               </a:defRPr>
             </a:pPr>
             <a:r>
-              <a:t>Browser click events propagate upwards through all DOM parent containers automatically.</a:t>
+              <a:t>repos.reduce((acc, repo) =&gt; acc + repo.stargazers_count, 0) aggregates total star counts across 100+ repositories in O(N) linear time.</a:t>
             </a:r>
           </a:p>
           <a:p>
@@ -5915,14 +6600,14 @@
               <a:spcAft>
                 <a:spcPts val="200"/>
               </a:spcAft>
-              <a:defRPr sz="1250" b="1">
+              <a:defRPr sz="1200" b="1">
                 <a:solidFill>
                   <a:srgbClr val="FCD34D"/>
                 </a:solidFill>
               </a:defRPr>
             </a:pPr>
             <a:r>
-              <a:t>🎯  Single Container Listener</a:t>
+              <a:t>📊  Total Forks Aggregation (app.js: L232)</a:t>
             </a:r>
           </a:p>
           <a:p>
@@ -5930,14 +6615,14 @@
               <a:spcAft>
                 <a:spcPts val="1000"/>
               </a:spcAft>
-              <a:defRPr sz="1100">
+              <a:defRPr sz="1050">
                 <a:solidFill>
                   <a:srgbClr val="E4E4E7"/>
                 </a:solidFill>
               </a:defRPr>
             </a:pPr>
             <a:r>
-              <a:t>Attached 1 single listener to the parent container instead of binding 50+ individual button listeners. Eliminates memory leaks.</a:t>
+              <a:t>repos.reduce((acc, repo) =&gt; acc + repo.forks_count, 0) accumulates community fork metrics.</a:t>
             </a:r>
           </a:p>
           <a:p>
@@ -5945,14 +6630,14 @@
               <a:spcAft>
                 <a:spcPts val="200"/>
               </a:spcAft>
-              <a:defRPr sz="1250" b="1">
+              <a:defRPr sz="1200" b="1">
                 <a:solidFill>
                   <a:srgbClr val="FCD34D"/>
                 </a:solidFill>
               </a:defRPr>
             </a:pPr>
             <a:r>
-              <a:t>🎯  Dynamic Interception via closest()</a:t>
+              <a:t>📊  Top Language Frequency Map (app.js: L237)</a:t>
             </a:r>
           </a:p>
           <a:p>
@@ -5960,14 +6645,14 @@
               <a:spcAft>
                 <a:spcPts val="1000"/>
               </a:spcAft>
-              <a:defRPr sz="1100">
+              <a:defRPr sz="1050">
                 <a:solidFill>
                   <a:srgbClr val="E4E4E7"/>
                 </a:solidFill>
               </a:defRPr>
             </a:pPr>
             <a:r>
-              <a:t>event.target.closest('.tag-btn') reliably intercepts clicks on nested child icons and text spans.</a:t>
+              <a:t>.reduce() constructs a dynamic frequency dictionary: { JavaScript: 15, TypeScript: 8, Python: 3 } to determine developer specialty.</a:t>
             </a:r>
           </a:p>
           <a:p>
@@ -5975,14 +6660,14 @@
               <a:spcAft>
                 <a:spcPts val="200"/>
               </a:spcAft>
-              <a:defRPr sz="1250" b="1">
+              <a:defRPr sz="1200" b="1">
                 <a:solidFill>
                   <a:srgbClr val="FCD34D"/>
                 </a:solidFill>
               </a:defRPr>
             </a:pPr>
             <a:r>
-              <a:t>🎯  LocalStorage State Persistence</a:t>
+              <a:t>📊  Immutability &amp; Spread (app.js: L259, L273)</a:t>
             </a:r>
           </a:p>
           <a:p>
@@ -5990,14 +6675,14 @@
               <a:spcAft>
                 <a:spcPts val="1000"/>
               </a:spcAft>
-              <a:defRPr sz="1100">
+              <a:defRPr sz="1050">
                 <a:solidFill>
                   <a:srgbClr val="E4E4E7"/>
                 </a:solidFill>
               </a:defRPr>
             </a:pPr>
             <a:r>
-              <a:t>Serializes bookmarks with JSON.stringify and restores them on page reload with JSON.parse.</a:t>
+              <a:t>const languages = [...new Set(...)]; and let result = [...this.currentRepos] guarantee original API state is never mutated.</a:t>
             </a:r>
           </a:p>
         </p:txBody>
@@ -6010,14 +6695,14 @@
         </p:nvSpPr>
         <p:spPr>
           <a:xfrm>
-            <a:off x="6217920" y="1554480"/>
-            <a:ext cx="5242255" cy="4754880"/>
+            <a:off x="6217920" y="1463040"/>
+            <a:ext cx="5242255" cy="4846320"/>
           </a:xfrm>
           <a:prstGeom prst="roundRect">
             <a:avLst/>
           </a:prstGeom>
           <a:solidFill>
-            <a:srgbClr val="1A1A1E"/>
+            <a:srgbClr val="0F0F12"/>
           </a:solidFill>
           <a:ln w="12700">
             <a:solidFill>
@@ -6047,30 +6732,123 @@
           </a:p>
         </p:txBody>
       </p:sp>
-      <p:pic>
-        <p:nvPicPr>
-          <p:cNvPr id="9" name="Picture 8" descr="dom_delegation_diagram.png"/>
-          <p:cNvPicPr>
-            <a:picLocks noChangeAspect="1"/>
-          </p:cNvPicPr>
+      <p:sp>
+        <p:nvSpPr>
+          <p:cNvPr id="9" name="TextBox 8"/>
+          <p:cNvSpPr txBox="1"/>
           <p:nvPr/>
-        </p:nvPicPr>
-        <p:blipFill>
-          <a:blip r:embed="rId2"/>
-          <a:stretch>
-            <a:fillRect/>
-          </a:stretch>
-        </p:blipFill>
-        <p:spPr>
-          <a:xfrm>
-            <a:off x="6355080" y="1691640"/>
-            <a:ext cx="4967935" cy="4036447"/>
+        </p:nvSpPr>
+        <p:spPr>
+          <a:xfrm>
+            <a:off x="6400800" y="1645920"/>
+            <a:ext cx="4876495" cy="4389120"/>
           </a:xfrm>
           <a:prstGeom prst="rect">
             <a:avLst/>
           </a:prstGeom>
-        </p:spPr>
-      </p:pic>
+          <a:noFill/>
+        </p:spPr>
+        <p:txBody>
+          <a:bodyPr wrap="square" lIns="0" tIns="0" rIns="0" bIns="0">
+            <a:spAutoFit/>
+          </a:bodyPr>
+          <a:lstStyle/>
+          <a:p>
+            <a:pPr>
+              <a:spcAft>
+                <a:spcPts val="1000"/>
+              </a:spcAft>
+              <a:defRPr sz="1300" b="1">
+                <a:solidFill>
+                  <a:srgbClr val="F59E0B"/>
+                </a:solidFill>
+              </a:defRPr>
+            </a:pPr>
+            <a:r>
+              <a:t>📄 app.js: Lines 228–248 (computeAnalytics)</a:t>
+            </a:r>
+          </a:p>
+          <a:p>
+            <a:pPr>
+              <a:defRPr sz="950">
+                <a:solidFill>
+                  <a:srgbClr val="FBBF24"/>
+                </a:solidFill>
+                <a:latin typeface="Consolas"/>
+              </a:defRPr>
+            </a:pPr>
+            <a:r>
+              <a:t>// 1. Total Stars Calculation (.reduce single-pass)</a:t>
+            </a:r>
+            <a:br/>
+            <a:r>
+              <a:t>const totalStars = repos.reduce((acc, repo) =&gt; </a:t>
+            </a:r>
+            <a:br/>
+            <a:r>
+              <a:t>  acc + (repo.stargazers_count || 0), 0</a:t>
+            </a:r>
+            <a:br/>
+            <a:r>
+              <a:t>);</a:t>
+            </a:r>
+            <a:br/>
+            <a:r>
+              <a:t>this.metricTotalStars.textContent = totalStars.toLocaleString();</a:t>
+            </a:r>
+            <a:br/>
+            <a:br/>
+            <a:r>
+              <a:t>// 2. Language Frequency Map Generator (.reduce)</a:t>
+            </a:r>
+            <a:br/>
+            <a:r>
+              <a:t>const langCounts = repos.reduce((acc, repo) =&gt; {</a:t>
+            </a:r>
+            <a:br/>
+            <a:r>
+              <a:t>  if (repo.language) {</a:t>
+            </a:r>
+            <a:br/>
+            <a:r>
+              <a:t>    acc[repo.language] = (acc[repo.language] || 0) + 1;</a:t>
+            </a:r>
+            <a:br/>
+            <a:r>
+              <a:t>  }</a:t>
+            </a:r>
+            <a:br/>
+            <a:r>
+              <a:t>  return acc;</a:t>
+            </a:r>
+            <a:br/>
+            <a:r>
+              <a:t>}, {}); // Output: { JavaScript: 15, Python: 4 }</a:t>
+            </a:r>
+            <a:br/>
+            <a:br/>
+            <a:r>
+              <a:t>// 3. Extract Dominant Language</a:t>
+            </a:r>
+            <a:br/>
+            <a:r>
+              <a:t>let topLang = 'JavaScript', maxCount = 0;</a:t>
+            </a:r>
+            <a:br/>
+            <a:r>
+              <a:t>for (const [lang, count] of Object.entries(langCounts)) {</a:t>
+            </a:r>
+            <a:br/>
+            <a:r>
+              <a:t>  if (count &gt; maxCount) { maxCount = count; topLang = lang; }</a:t>
+            </a:r>
+            <a:br/>
+            <a:r>
+              <a:t>}</a:t>
+            </a:r>
+          </a:p>
+        </p:txBody>
+      </p:sp>
     </p:spTree>
   </p:cSld>
   <p:clrMapOvr>
@@ -6140,7 +6918,7 @@
         </p:nvSpPr>
         <p:spPr>
           <a:xfrm>
-            <a:off x="731520" y="411480"/>
+            <a:off x="731520" y="365760"/>
             <a:ext cx="7315200" cy="320040"/>
           </a:xfrm>
           <a:prstGeom prst="rect">
@@ -6162,7 +6940,7 @@
               </a:defRPr>
             </a:pPr>
             <a:r>
-              <a:t>DAY 04 BACKEND ARCHITECTURE</a:t>
+              <a:t>DOM &amp; STORAGE</a:t>
             </a:r>
           </a:p>
         </p:txBody>
@@ -6175,7 +6953,7 @@
         </p:nvSpPr>
         <p:spPr>
           <a:xfrm>
-            <a:off x="731520" y="731520"/>
+            <a:off x="731520" y="658368"/>
             <a:ext cx="10698480" cy="548640"/>
           </a:xfrm>
           <a:prstGeom prst="rect">
@@ -6190,14 +6968,14 @@
           <a:lstStyle/>
           <a:p>
             <a:pPr>
-              <a:defRPr sz="2400" b="1">
+              <a:defRPr sz="2300" b="1">
                 <a:solidFill>
                   <a:srgbClr val="FFFFFF"/>
                 </a:solidFill>
               </a:defRPr>
             </a:pPr>
             <a:r>
-              <a:t>Node.js Core Runtime &amp; Asynchronous FileSystem</a:t>
+              <a:t>Mini-Project: Event Delegation &amp; LocalStorage</a:t>
             </a:r>
           </a:p>
         </p:txBody>
@@ -6210,7 +6988,7 @@
         </p:nvSpPr>
         <p:spPr>
           <a:xfrm>
-            <a:off x="731520" y="1325880"/>
+            <a:off x="731520" y="1234440"/>
             <a:ext cx="10728655" cy="13716"/>
           </a:xfrm>
           <a:prstGeom prst="rect">
@@ -6253,8 +7031,8 @@
         </p:nvSpPr>
         <p:spPr>
           <a:xfrm>
-            <a:off x="731520" y="1554480"/>
-            <a:ext cx="5212080" cy="4754880"/>
+            <a:off x="731520" y="1463040"/>
+            <a:ext cx="5212080" cy="4846320"/>
           </a:xfrm>
           <a:prstGeom prst="roundRect">
             <a:avLst/>
@@ -6298,8 +7076,8 @@
         </p:nvSpPr>
         <p:spPr>
           <a:xfrm>
-            <a:off x="1005840" y="1737360"/>
-            <a:ext cx="4663440" cy="4297680"/>
+            <a:off x="1005840" y="1645920"/>
+            <a:ext cx="4663440" cy="4389120"/>
           </a:xfrm>
           <a:prstGeom prst="rect">
             <a:avLst/>
@@ -6314,16 +7092,16 @@
           <a:p>
             <a:pPr>
               <a:spcAft>
-                <a:spcPts val="1600"/>
-              </a:spcAft>
-              <a:defRPr sz="1800" b="1">
+                <a:spcPts val="1400"/>
+              </a:spcAft>
+              <a:defRPr sz="1700" b="1">
                 <a:solidFill>
                   <a:srgbClr val="FFFFFF"/>
                 </a:solidFill>
               </a:defRPr>
             </a:pPr>
             <a:r>
-              <a:t>Server-Side Execution &amp; fs/promises</a:t>
+              <a:t>Memory Efficiency &amp; Client Persistence</a:t>
             </a:r>
           </a:p>
           <a:p>
@@ -6331,14 +7109,14 @@
               <a:spcAft>
                 <a:spcPts val="200"/>
               </a:spcAft>
-              <a:defRPr sz="1250" b="1">
+              <a:defRPr sz="1200" b="1">
                 <a:solidFill>
                   <a:srgbClr val="FCD34D"/>
                 </a:solidFill>
               </a:defRPr>
             </a:pPr>
             <a:r>
-              <a:t>🟢  Server V8 + Libuv Architecture</a:t>
+              <a:t>🎯  Single Container Listener (app.js: L102, L141)</a:t>
             </a:r>
           </a:p>
           <a:p>
@@ -6346,14 +7124,14 @@
               <a:spcAft>
                 <a:spcPts val="1000"/>
               </a:spcAft>
-              <a:defRPr sz="1100">
+              <a:defRPr sz="1050">
                 <a:solidFill>
                   <a:srgbClr val="E4E4E7"/>
                 </a:solidFill>
               </a:defRPr>
             </a:pPr>
             <a:r>
-              <a:t>JavaScript executing outside the browser sandbox with multi-threaded C++ Libuv handling non-blocking OS I/O.</a:t>
+              <a:t>Instead of binding 50+ listeners, attached 1 listener to #bookmarks-grid and #quick-tags-container. Prevents memory leaks.</a:t>
             </a:r>
           </a:p>
           <a:p>
@@ -6361,14 +7139,14 @@
               <a:spcAft>
                 <a:spcPts val="200"/>
               </a:spcAft>
-              <a:defRPr sz="1250" b="1">
+              <a:defRPr sz="1200" b="1">
                 <a:solidFill>
                   <a:srgbClr val="FCD34D"/>
                 </a:solidFill>
               </a:defRPr>
             </a:pPr>
             <a:r>
-              <a:t>🟢  CommonJS Module Standard</a:t>
+              <a:t>🎯  Event Bubbling &amp; closest() (app.js: L104, L142)</a:t>
             </a:r>
           </a:p>
           <a:p>
@@ -6376,14 +7154,14 @@
               <a:spcAft>
                 <a:spcPts val="1000"/>
               </a:spcAft>
-              <a:defRPr sz="1100">
+              <a:defRPr sz="1050">
                 <a:solidFill>
                   <a:srgbClr val="E4E4E7"/>
                 </a:solidFill>
               </a:defRPr>
             </a:pPr>
             <a:r>
-              <a:t>Explicit encapsulation and sharing via require() imports and module.exports.</a:t>
+              <a:t>Clicks bubble upwards; e.target.closest('.tag-btn') reliably extracts dataset.user even if user clicked inner icons or spans.</a:t>
             </a:r>
           </a:p>
           <a:p>
@@ -6391,14 +7169,14 @@
               <a:spcAft>
                 <a:spcPts val="200"/>
               </a:spcAft>
-              <a:defRPr sz="1250" b="1">
+              <a:defRPr sz="1200" b="1">
                 <a:solidFill>
                   <a:srgbClr val="FCD34D"/>
                 </a:solidFill>
               </a:defRPr>
             </a:pPr>
             <a:r>
-              <a:t>🟢  Non-Blocking fs/promises Module</a:t>
+              <a:t>🎯  JSON Serialization Protocol (app.js: L505, L517)</a:t>
             </a:r>
           </a:p>
           <a:p>
@@ -6406,14 +7184,14 @@
               <a:spcAft>
                 <a:spcPts val="1000"/>
               </a:spcAft>
-              <a:defRPr sz="1100">
+              <a:defRPr sz="1050">
                 <a:solidFill>
                   <a:srgbClr val="E4E4E7"/>
                 </a:solidFill>
               </a:defRPr>
             </a:pPr>
             <a:r>
-              <a:t>Asynchronous file I/O (readFile, writeFile, appendFile) maintaining full server responsiveness.</a:t>
+              <a:t>localStorage only stores strings. Used JSON.stringify() to serialize array state, and JSON.parse() on load.</a:t>
             </a:r>
           </a:p>
           <a:p>
@@ -6421,14 +7199,14 @@
               <a:spcAft>
                 <a:spcPts val="200"/>
               </a:spcAft>
-              <a:defRPr sz="1250" b="1">
+              <a:defRPr sz="1200" b="1">
                 <a:solidFill>
                   <a:srgbClr val="FCD34D"/>
                 </a:solidFill>
               </a:defRPr>
             </a:pPr>
             <a:r>
-              <a:t>🟢  Safe Cross-Platform Paths</a:t>
+              <a:t>🎯  State Sync (.some &amp; Badges) (app.js: L406)</a:t>
             </a:r>
           </a:p>
           <a:p>
@@ -6436,14 +7214,14 @@
               <a:spcAft>
                 <a:spcPts val="1000"/>
               </a:spcAft>
-              <a:defRPr sz="1100">
+              <a:defRPr sz="1050">
                 <a:solidFill>
                   <a:srgbClr val="E4E4E7"/>
                 </a:solidFill>
               </a:defRPr>
             </a:pPr>
             <a:r>
-              <a:t>path.join(__dirname, 'file.json') prevents operating system path separator conflicts.</a:t>
+              <a:t>this.bookmarks.some() syncs Star bookmark toggle button and updates navbar badge counts automatically.</a:t>
             </a:r>
           </a:p>
         </p:txBody>
@@ -6456,14 +7234,14 @@
         </p:nvSpPr>
         <p:spPr>
           <a:xfrm>
-            <a:off x="6217920" y="1554480"/>
-            <a:ext cx="5242255" cy="4754880"/>
+            <a:off x="6217920" y="1463040"/>
+            <a:ext cx="5242255" cy="4846320"/>
           </a:xfrm>
           <a:prstGeom prst="roundRect">
             <a:avLst/>
           </a:prstGeom>
           <a:solidFill>
-            <a:srgbClr val="1A1A1E"/>
+            <a:srgbClr val="0F0F12"/>
           </a:solidFill>
           <a:ln w="12700">
             <a:solidFill>
@@ -6493,30 +7271,119 @@
           </a:p>
         </p:txBody>
       </p:sp>
-      <p:pic>
-        <p:nvPicPr>
-          <p:cNvPr id="9" name="Picture 8" descr="node_arch_diagram.png"/>
-          <p:cNvPicPr>
-            <a:picLocks noChangeAspect="1"/>
-          </p:cNvPicPr>
+      <p:sp>
+        <p:nvSpPr>
+          <p:cNvPr id="9" name="TextBox 8"/>
+          <p:cNvSpPr txBox="1"/>
           <p:nvPr/>
-        </p:nvPicPr>
-        <p:blipFill>
-          <a:blip r:embed="rId2"/>
-          <a:stretch>
-            <a:fillRect/>
-          </a:stretch>
-        </p:blipFill>
-        <p:spPr>
-          <a:xfrm>
-            <a:off x="6355080" y="1691640"/>
-            <a:ext cx="4967935" cy="4036447"/>
+        </p:nvSpPr>
+        <p:spPr>
+          <a:xfrm>
+            <a:off x="6400800" y="1645920"/>
+            <a:ext cx="4876495" cy="4389120"/>
           </a:xfrm>
           <a:prstGeom prst="rect">
             <a:avLst/>
           </a:prstGeom>
-        </p:spPr>
-      </p:pic>
+          <a:noFill/>
+        </p:spPr>
+        <p:txBody>
+          <a:bodyPr wrap="square" lIns="0" tIns="0" rIns="0" bIns="0">
+            <a:spAutoFit/>
+          </a:bodyPr>
+          <a:lstStyle/>
+          <a:p>
+            <a:pPr>
+              <a:spcAft>
+                <a:spcPts val="1000"/>
+              </a:spcAft>
+              <a:defRPr sz="1300" b="1">
+                <a:solidFill>
+                  <a:srgbClr val="F59E0B"/>
+                </a:solidFill>
+              </a:defRPr>
+            </a:pPr>
+            <a:r>
+              <a:t>📄 app.js: Lines 102–145, 505–523</a:t>
+            </a:r>
+          </a:p>
+          <a:p>
+            <a:pPr>
+              <a:defRPr sz="950">
+                <a:solidFill>
+                  <a:srgbClr val="60A5FA"/>
+                </a:solidFill>
+                <a:latin typeface="Consolas"/>
+              </a:defRPr>
+            </a:pPr>
+            <a:r>
+              <a:t>// 1. Event Delegation on Parent Grid (app.js: L141)</a:t>
+            </a:r>
+            <a:br/>
+            <a:r>
+              <a:t>this.bookmarksGrid.addEventListener('click', (e) =&gt; {</a:t>
+            </a:r>
+            <a:br/>
+            <a:r>
+              <a:t>  const btnInspect = e.target.closest('.btn-inspect-dev');</a:t>
+            </a:r>
+            <a:br/>
+            <a:r>
+              <a:t>  const btnRemove = e.target.closest('.btn-remove-bookmark');</a:t>
+            </a:r>
+            <a:br/>
+            <a:r>
+              <a:t>  if (btnInspect) this.fetchDeveloperProfile(btnInspect.dataset.user);</a:t>
+            </a:r>
+            <a:br/>
+            <a:r>
+              <a:t>  if (btnRemove) this.removeBookmark(btnRemove.dataset.user);</a:t>
+            </a:r>
+            <a:br/>
+            <a:r>
+              <a:t>});</a:t>
+            </a:r>
+            <a:br/>
+            <a:br/>
+            <a:r>
+              <a:t>// 2. LocalStorage Read Protocol (app.js: L505)</a:t>
+            </a:r>
+            <a:br/>
+            <a:r>
+              <a:t>#loadBookmarksFromStorage() {</a:t>
+            </a:r>
+            <a:br/>
+            <a:r>
+              <a:t>  const data = localStorage.getItem(this.#STORAGE_KEY);</a:t>
+            </a:r>
+            <a:br/>
+            <a:r>
+              <a:t>  return data ? JSON.parse(data) : []; // String -&gt; Array</a:t>
+            </a:r>
+            <a:br/>
+            <a:r>
+              <a:t>}</a:t>
+            </a:r>
+            <a:br/>
+            <a:br/>
+            <a:r>
+              <a:t>// 3. LocalStorage Write Protocol (app.js: L517)</a:t>
+            </a:r>
+            <a:br/>
+            <a:r>
+              <a:t>#saveBookmarksToStorage() {</a:t>
+            </a:r>
+            <a:br/>
+            <a:r>
+              <a:t>  localStorage.setItem(this.#STORAGE_KEY, JSON.stringify(this.bookmarks));</a:t>
+            </a:r>
+            <a:br/>
+            <a:r>
+              <a:t>}</a:t>
+            </a:r>
+          </a:p>
+        </p:txBody>
+      </p:sp>
     </p:spTree>
   </p:cSld>
   <p:clrMapOvr>
@@ -6586,7 +7453,7 @@
         </p:nvSpPr>
         <p:spPr>
           <a:xfrm>
-            <a:off x="731520" y="411480"/>
+            <a:off x="731520" y="365760"/>
             <a:ext cx="7315200" cy="320040"/>
           </a:xfrm>
           <a:prstGeom prst="rect">
@@ -6608,7 +7475,7 @@
               </a:defRPr>
             </a:pPr>
             <a:r>
-              <a:t>PROJECT SHOWCASE &amp; LIVE DEMO</a:t>
+              <a:t>DAY 04 BACKEND</a:t>
             </a:r>
           </a:p>
         </p:txBody>
@@ -6621,7 +7488,7 @@
         </p:nvSpPr>
         <p:spPr>
           <a:xfrm>
-            <a:off x="731520" y="731520"/>
+            <a:off x="731520" y="658368"/>
             <a:ext cx="10698480" cy="548640"/>
           </a:xfrm>
           <a:prstGeom prst="rect">
@@ -6636,14 +7503,14 @@
           <a:lstStyle/>
           <a:p>
             <a:pPr>
-              <a:defRPr sz="2400" b="1">
+              <a:defRPr sz="2300" b="1">
                 <a:solidFill>
                   <a:srgbClr val="FFFFFF"/>
                 </a:solidFill>
               </a:defRPr>
             </a:pPr>
             <a:r>
-              <a:t>Live Demonstration: DevExplorer PRO v2.0</a:t>
+              <a:t>Day 04: Node.js V8 Runtime &amp; Asynchronous FileSystem</a:t>
             </a:r>
           </a:p>
         </p:txBody>
@@ -6656,7 +7523,7 @@
         </p:nvSpPr>
         <p:spPr>
           <a:xfrm>
-            <a:off x="731520" y="1325880"/>
+            <a:off x="731520" y="1234440"/>
             <a:ext cx="10728655" cy="13716"/>
           </a:xfrm>
           <a:prstGeom prst="rect">
@@ -6699,8 +7566,8 @@
         </p:nvSpPr>
         <p:spPr>
           <a:xfrm>
-            <a:off x="731520" y="1554480"/>
-            <a:ext cx="5212080" cy="4754880"/>
+            <a:off x="731520" y="1463040"/>
+            <a:ext cx="5212080" cy="4846320"/>
           </a:xfrm>
           <a:prstGeom prst="roundRect">
             <a:avLst/>
@@ -6744,8 +7611,8 @@
         </p:nvSpPr>
         <p:spPr>
           <a:xfrm>
-            <a:off x="1005840" y="1737360"/>
-            <a:ext cx="4663440" cy="4297680"/>
+            <a:off x="1005840" y="1645920"/>
+            <a:ext cx="4663440" cy="4389120"/>
           </a:xfrm>
           <a:prstGeom prst="rect">
             <a:avLst/>
@@ -6760,37 +7627,37 @@
           <a:p>
             <a:pPr>
               <a:spcAft>
-                <a:spcPts val="1600"/>
-              </a:spcAft>
-              <a:defRPr sz="1800" b="1">
+                <a:spcPts val="1400"/>
+              </a:spcAft>
+              <a:defRPr sz="1700" b="1">
                 <a:solidFill>
                   <a:srgbClr val="FFFFFF"/>
                 </a:solidFill>
               </a:defRPr>
             </a:pPr>
             <a:r>
-              <a:t>Featured Architecture Highlights</a:t>
-            </a:r>
-          </a:p>
-          <a:p>
-            <a:pPr>
-              <a:spcAft>
-                <a:spcPts val="100"/>
+              <a:t>Server-Side V8 &amp; Non-Blocking FileSystem</a:t>
+            </a:r>
+          </a:p>
+          <a:p>
+            <a:pPr>
+              <a:spcAft>
+                <a:spcPts val="200"/>
               </a:spcAft>
               <a:defRPr sz="1200" b="1">
                 <a:solidFill>
-                  <a:srgbClr val="F59E0B"/>
-                </a:solidFill>
-              </a:defRPr>
-            </a:pPr>
-            <a:r>
-              <a:t>🚀  1. Parallel API Fetching</a:t>
-            </a:r>
-          </a:p>
-          <a:p>
-            <a:pPr>
-              <a:spcAft>
-                <a:spcPts val="800"/>
+                  <a:srgbClr val="FCD34D"/>
+                </a:solidFill>
+              </a:defRPr>
+            </a:pPr>
+            <a:r>
+              <a:t>🟢  V8 Runtime + Libuv C++ Layer</a:t>
+            </a:r>
+          </a:p>
+          <a:p>
+            <a:pPr>
+              <a:spcAft>
+                <a:spcPts val="1000"/>
               </a:spcAft>
               <a:defRPr sz="1050">
                 <a:solidFill>
@@ -6799,28 +7666,28 @@
               </a:defRPr>
             </a:pPr>
             <a:r>
-              <a:t>Fetches GitHub User Profile and Repositories concurrently via Promise.all() with shimmer loading states.</a:t>
-            </a:r>
-          </a:p>
-          <a:p>
-            <a:pPr>
-              <a:spcAft>
-                <a:spcPts val="100"/>
+              <a:t>Chrome V8 translates JS to machine code while multi-threaded Libuv executes background disk I/O without blocking server traffic.</a:t>
+            </a:r>
+          </a:p>
+          <a:p>
+            <a:pPr>
+              <a:spcAft>
+                <a:spcPts val="200"/>
               </a:spcAft>
               <a:defRPr sz="1200" b="1">
                 <a:solidFill>
-                  <a:srgbClr val="F59E0B"/>
-                </a:solidFill>
-              </a:defRPr>
-            </a:pPr>
-            <a:r>
-              <a:t>🚀  2. Real-Time Analytics Engine</a:t>
-            </a:r>
-          </a:p>
-          <a:p>
-            <a:pPr>
-              <a:spcAft>
-                <a:spcPts val="800"/>
+                  <a:srgbClr val="FCD34D"/>
+                </a:solidFill>
+              </a:defRPr>
+            </a:pPr>
+            <a:r>
+              <a:t>🟢  Non-Blocking fs/promises Module</a:t>
+            </a:r>
+          </a:p>
+          <a:p>
+            <a:pPr>
+              <a:spcAft>
+                <a:spcPts val="1000"/>
               </a:spcAft>
               <a:defRPr sz="1050">
                 <a:solidFill>
@@ -6829,28 +7696,28 @@
               </a:defRPr>
             </a:pPr>
             <a:r>
-              <a:t>Calculates Total Stars, Fork count, and Top Language using a single-pass .reduce() pipeline.</a:t>
-            </a:r>
-          </a:p>
-          <a:p>
-            <a:pPr>
-              <a:spcAft>
-                <a:spcPts val="100"/>
+              <a:t>Replaced synchronous fs.readFileSync with await fs.readFile / fs.writeFile. Keeps main Event Loop 100% responsive.</a:t>
+            </a:r>
+          </a:p>
+          <a:p>
+            <a:pPr>
+              <a:spcAft>
+                <a:spcPts val="200"/>
               </a:spcAft>
               <a:defRPr sz="1200" b="1">
                 <a:solidFill>
-                  <a:srgbClr val="F59E0B"/>
-                </a:solidFill>
-              </a:defRPr>
-            </a:pPr>
-            <a:r>
-              <a:t>🚀  3. Event Delegation Tag Cloud</a:t>
-            </a:r>
-          </a:p>
-          <a:p>
-            <a:pPr>
-              <a:spcAft>
-                <a:spcPts val="800"/>
+                  <a:srgbClr val="FCD34D"/>
+                </a:solidFill>
+              </a:defRPr>
+            </a:pPr>
+            <a:r>
+              <a:t>🟢  Cross-Platform path.join(__dirname, ...)</a:t>
+            </a:r>
+          </a:p>
+          <a:p>
+            <a:pPr>
+              <a:spcAft>
+                <a:spcPts val="1000"/>
               </a:spcAft>
               <a:defRPr sz="1050">
                 <a:solidFill>
@@ -6859,28 +7726,28 @@
               </a:defRPr>
             </a:pPr>
             <a:r>
-              <a:t>1-click developer exploration (torvalds, gaearon, wasi-747) handled by a single container listener.</a:t>
-            </a:r>
-          </a:p>
-          <a:p>
-            <a:pPr>
-              <a:spcAft>
-                <a:spcPts val="100"/>
+              <a:t>Normalizes path separators (Windows backslash vs POSIX forward slash) preventing production deployment path crashes.</a:t>
+            </a:r>
+          </a:p>
+          <a:p>
+            <a:pPr>
+              <a:spcAft>
+                <a:spcPts val="200"/>
               </a:spcAft>
               <a:defRPr sz="1200" b="1">
                 <a:solidFill>
-                  <a:srgbClr val="F59E0B"/>
-                </a:solidFill>
-              </a:defRPr>
-            </a:pPr>
-            <a:r>
-              <a:t>🚀  4. LocalStorage State Sync</a:t>
-            </a:r>
-          </a:p>
-          <a:p>
-            <a:pPr>
-              <a:spcAft>
-                <a:spcPts val="800"/>
+                  <a:srgbClr val="FCD34D"/>
+                </a:solidFill>
+              </a:defRPr>
+            </a:pPr>
+            <a:r>
+              <a:t>🟢  Backend Analytics Logging Pipeline</a:t>
+            </a:r>
+          </a:p>
+          <a:p>
+            <a:pPr>
+              <a:spcAft>
+                <a:spcPts val="1000"/>
               </a:spcAft>
               <a:defRPr sz="1050">
                 <a:solidFill>
@@ -6889,37 +7756,7 @@
               </a:defRPr>
             </a:pPr>
             <a:r>
-              <a:t>Persists bookmarked developer profiles client-side across browser sessions.</a:t>
-            </a:r>
-          </a:p>
-          <a:p>
-            <a:pPr>
-              <a:spcAft>
-                <a:spcPts val="100"/>
-              </a:spcAft>
-              <a:defRPr sz="1200" b="1">
-                <a:solidFill>
-                  <a:srgbClr val="F59E0B"/>
-                </a:solidFill>
-              </a:defRPr>
-            </a:pPr>
-            <a:r>
-              <a:t>🚀  5. Resilient Error Handling</a:t>
-            </a:r>
-          </a:p>
-          <a:p>
-            <a:pPr>
-              <a:spcAft>
-                <a:spcPts val="800"/>
-              </a:spcAft>
-              <a:defRPr sz="1050">
-                <a:solidFill>
-                  <a:srgbClr val="E4E4E7"/>
-                </a:solidFill>
-              </a:defRPr>
-            </a:pPr>
-            <a:r>
-              <a:t>Graceful API rate-limit detection, custom 404 cards, and auto-dismissing toast notifications.</a:t>
+              <a:t>Automated Node.js script reads, aggregates, and persists DevExplorer telemetry snapshots to disk asynchronously.</a:t>
             </a:r>
           </a:p>
         </p:txBody>
@@ -6932,14 +7769,14 @@
         </p:nvSpPr>
         <p:spPr>
           <a:xfrm>
-            <a:off x="6217920" y="1554480"/>
-            <a:ext cx="5242255" cy="4754880"/>
+            <a:off x="6217920" y="1463040"/>
+            <a:ext cx="5242255" cy="4846320"/>
           </a:xfrm>
           <a:prstGeom prst="roundRect">
             <a:avLst/>
           </a:prstGeom>
           <a:solidFill>
-            <a:srgbClr val="1A1A1E"/>
+            <a:srgbClr val="0F0F12"/>
           </a:solidFill>
           <a:ln w="12700">
             <a:solidFill>
@@ -6969,30 +7806,120 @@
           </a:p>
         </p:txBody>
       </p:sp>
-      <p:pic>
-        <p:nvPicPr>
-          <p:cNvPr id="9" name="Picture 8" descr="devexplorer_ui.png"/>
-          <p:cNvPicPr>
-            <a:picLocks noChangeAspect="1"/>
-          </p:cNvPicPr>
+      <p:sp>
+        <p:nvSpPr>
+          <p:cNvPr id="9" name="TextBox 8"/>
+          <p:cNvSpPr txBox="1"/>
           <p:nvPr/>
-        </p:nvPicPr>
-        <p:blipFill>
-          <a:blip r:embed="rId2"/>
-          <a:stretch>
-            <a:fillRect/>
-          </a:stretch>
-        </p:blipFill>
-        <p:spPr>
-          <a:xfrm>
-            <a:off x="6355080" y="1691640"/>
-            <a:ext cx="4967935" cy="3182583"/>
+        </p:nvSpPr>
+        <p:spPr>
+          <a:xfrm>
+            <a:off x="6400800" y="1645920"/>
+            <a:ext cx="4876495" cy="4389120"/>
           </a:xfrm>
           <a:prstGeom prst="rect">
             <a:avLst/>
           </a:prstGeom>
-        </p:spPr>
-      </p:pic>
+          <a:noFill/>
+        </p:spPr>
+        <p:txBody>
+          <a:bodyPr wrap="square" lIns="0" tIns="0" rIns="0" bIns="0">
+            <a:spAutoFit/>
+          </a:bodyPr>
+          <a:lstStyle/>
+          <a:p>
+            <a:pPr>
+              <a:spcAft>
+                <a:spcPts val="1000"/>
+              </a:spcAft>
+              <a:defRPr sz="1300" b="1">
+                <a:solidFill>
+                  <a:srgbClr val="F59E0B"/>
+                </a:solidFill>
+              </a:defRPr>
+            </a:pPr>
+            <a:r>
+              <a:t>📄 Node.js: practice-snippets.js (fs/promises)</a:t>
+            </a:r>
+          </a:p>
+          <a:p>
+            <a:pPr>
+              <a:defRPr sz="950">
+                <a:solidFill>
+                  <a:srgbClr val="34D399"/>
+                </a:solidFill>
+                <a:latin typeface="Consolas"/>
+              </a:defRPr>
+            </a:pPr>
+            <a:r>
+              <a:t>const fs = require('fs/promises');</a:t>
+            </a:r>
+            <a:br/>
+            <a:r>
+              <a:t>const path = require('path');</a:t>
+            </a:r>
+            <a:br/>
+            <a:br/>
+            <a:r>
+              <a:t>async function saveAnalyticsLog(analyticsData) {</a:t>
+            </a:r>
+            <a:br/>
+            <a:r>
+              <a:t>  try {</a:t>
+            </a:r>
+            <a:br/>
+            <a:r>
+              <a:t>    // 1. Cross-Platform Safe Path</a:t>
+            </a:r>
+            <a:br/>
+            <a:r>
+              <a:t>    const logPath = path.join(__dirname, 'logs', 'analytics.json');</a:t>
+            </a:r>
+            <a:br/>
+            <a:br/>
+            <a:r>
+              <a:t>    // 2. Non-Blocking Asynchronous Disk Write</a:t>
+            </a:r>
+            <a:br/>
+            <a:r>
+              <a:t>    await fs.writeFile(logPath, JSON.stringify(analyticsData, null, 2));</a:t>
+            </a:r>
+            <a:br/>
+            <a:r>
+              <a:t>    console.log('✔ Non-blocking write completed!');</a:t>
+            </a:r>
+            <a:br/>
+            <a:br/>
+            <a:r>
+              <a:t>    // 3. Asynchronous Non-Blocking Disk Read</a:t>
+            </a:r>
+            <a:br/>
+            <a:r>
+              <a:t>    const raw = await fs.readFile(logPath, 'utf-8');</a:t>
+            </a:r>
+            <a:br/>
+            <a:r>
+              <a:t>    return JSON.parse(raw);</a:t>
+            </a:r>
+            <a:br/>
+            <a:r>
+              <a:t>  } catch (err) {</a:t>
+            </a:r>
+            <a:br/>
+            <a:r>
+              <a:t>    console.error('Disk I/O Error:', err.message);</a:t>
+            </a:r>
+            <a:br/>
+            <a:r>
+              <a:t>  }</a:t>
+            </a:r>
+            <a:br/>
+            <a:r>
+              <a:t>}</a:t>
+            </a:r>
+          </a:p>
+        </p:txBody>
+      </p:sp>
     </p:spTree>
   </p:cSld>
   <p:clrMapOvr>
@@ -7062,7 +7989,7 @@
         </p:nvSpPr>
         <p:spPr>
           <a:xfrm>
-            <a:off x="731520" y="411480"/>
+            <a:off x="731520" y="365760"/>
             <a:ext cx="7315200" cy="320040"/>
           </a:xfrm>
           <a:prstGeom prst="rect">
@@ -7084,7 +8011,7 @@
               </a:defRPr>
             </a:pPr>
             <a:r>
-              <a:t>LOOKING AHEAD</a:t>
+              <a:t>LIVE DEMO</a:t>
             </a:r>
           </a:p>
         </p:txBody>
@@ -7097,7 +8024,7 @@
         </p:nvSpPr>
         <p:spPr>
           <a:xfrm>
-            <a:off x="731520" y="731520"/>
+            <a:off x="731520" y="658368"/>
             <a:ext cx="10698480" cy="548640"/>
           </a:xfrm>
           <a:prstGeom prst="rect">
@@ -7112,14 +8039,14 @@
           <a:lstStyle/>
           <a:p>
             <a:pPr>
-              <a:defRPr sz="2400" b="1">
+              <a:defRPr sz="2300" b="1">
                 <a:solidFill>
                   <a:srgbClr val="FFFFFF"/>
                 </a:solidFill>
               </a:defRPr>
             </a:pPr>
             <a:r>
-              <a:t>Summary &amp; Readiness for Week 2 (React Deep Dive)</a:t>
+              <a:t>Live Demonstration Walkthrough &amp; Cheat Sheet</a:t>
             </a:r>
           </a:p>
         </p:txBody>
@@ -7132,7 +8059,7 @@
         </p:nvSpPr>
         <p:spPr>
           <a:xfrm>
-            <a:off x="731520" y="1325880"/>
+            <a:off x="731520" y="1234440"/>
             <a:ext cx="10728655" cy="13716"/>
           </a:xfrm>
           <a:prstGeom prst="rect">
@@ -7175,8 +8102,8 @@
         </p:nvSpPr>
         <p:spPr>
           <a:xfrm>
-            <a:off x="731520" y="1554480"/>
-            <a:ext cx="5212080" cy="4754880"/>
+            <a:off x="731520" y="1463040"/>
+            <a:ext cx="5257800" cy="1463040"/>
           </a:xfrm>
           <a:prstGeom prst="roundRect">
             <a:avLst/>
@@ -7220,8 +8147,8 @@
         </p:nvSpPr>
         <p:spPr>
           <a:xfrm>
-            <a:off x="1005840" y="1737360"/>
-            <a:ext cx="4663440" cy="4297680"/>
+            <a:off x="868680" y="1554480"/>
+            <a:ext cx="4983480" cy="1280160"/>
           </a:xfrm>
           <a:prstGeom prst="rect">
             <a:avLst/>
@@ -7236,136 +8163,43 @@
           <a:p>
             <a:pPr>
               <a:spcAft>
-                <a:spcPts val="1600"/>
-              </a:spcAft>
-              <a:defRPr sz="1800" b="1">
+                <a:spcPts val="200"/>
+              </a:spcAft>
+              <a:defRPr sz="1200" b="1">
+                <a:solidFill>
+                  <a:srgbClr val="FCD34D"/>
+                </a:solidFill>
+              </a:defRPr>
+            </a:pPr>
+            <a:r>
+              <a:t>Step 1: Search Trigger  (app.js: L94)</a:t>
+            </a:r>
+          </a:p>
+          <a:p>
+            <a:pPr>
+              <a:spcAft>
+                <a:spcPts val="200"/>
+              </a:spcAft>
+              <a:defRPr sz="1000" b="1">
                 <a:solidFill>
                   <a:srgbClr val="FFFFFF"/>
                 </a:solidFill>
               </a:defRPr>
             </a:pPr>
             <a:r>
-              <a:t>Week 1 Engineering Mastery</a:t>
-            </a:r>
-          </a:p>
-          <a:p>
-            <a:pPr>
-              <a:spcAft>
-                <a:spcPts val="200"/>
-              </a:spcAft>
-              <a:defRPr sz="1250" b="1">
-                <a:solidFill>
-                  <a:srgbClr val="FCD34D"/>
-                </a:solidFill>
-              </a:defRPr>
-            </a:pPr>
-            <a:r>
-              <a:t>✔  Semantic Web Standards</a:t>
-            </a:r>
-          </a:p>
-          <a:p>
-            <a:pPr>
-              <a:spcAft>
-                <a:spcPts val="1000"/>
-              </a:spcAft>
-              <a:defRPr sz="1100">
-                <a:solidFill>
-                  <a:srgbClr val="E4E4E7"/>
-                </a:solidFill>
-              </a:defRPr>
-            </a:pPr>
-            <a:r>
-              <a:t>HTML5 structure, 2D CSS Grid auto-fit matrices, and Tailwind utility tokens.</a:t>
-            </a:r>
-          </a:p>
-          <a:p>
-            <a:pPr>
-              <a:spcAft>
-                <a:spcPts val="200"/>
-              </a:spcAft>
-              <a:defRPr sz="1250" b="1">
-                <a:solidFill>
-                  <a:srgbClr val="FCD34D"/>
-                </a:solidFill>
-              </a:defRPr>
-            </a:pPr>
-            <a:r>
-              <a:t>✔  Production Git Strategy</a:t>
-            </a:r>
-          </a:p>
-          <a:p>
-            <a:pPr>
-              <a:spcAft>
-                <a:spcPts val="1000"/>
-              </a:spcAft>
-              <a:defRPr sz="1100">
-                <a:solidFill>
-                  <a:srgbClr val="E4E4E7"/>
-                </a:solidFill>
-              </a:defRPr>
-            </a:pPr>
-            <a:r>
-              <a:t>Locked main branch, atomic conventional commits, and Pull Request reviews.</a:t>
-            </a:r>
-          </a:p>
-          <a:p>
-            <a:pPr>
-              <a:spcAft>
-                <a:spcPts val="200"/>
-              </a:spcAft>
-              <a:defRPr sz="1250" b="1">
-                <a:solidFill>
-                  <a:srgbClr val="FCD34D"/>
-                </a:solidFill>
-              </a:defRPr>
-            </a:pPr>
-            <a:r>
-              <a:t>✔  Asynchronous Architecture</a:t>
-            </a:r>
-          </a:p>
-          <a:p>
-            <a:pPr>
-              <a:spcAft>
-                <a:spcPts val="1000"/>
-              </a:spcAft>
-              <a:defRPr sz="1100">
-                <a:solidFill>
-                  <a:srgbClr val="E4E4E7"/>
-                </a:solidFill>
-              </a:defRPr>
-            </a:pPr>
-            <a:r>
-              <a:t>Call Stack, Microtask queue priority, and non-blocking Promise pipelines.</a:t>
-            </a:r>
-          </a:p>
-          <a:p>
-            <a:pPr>
-              <a:spcAft>
-                <a:spcPts val="200"/>
-              </a:spcAft>
-              <a:defRPr sz="1250" b="1">
-                <a:solidFill>
-                  <a:srgbClr val="FCD34D"/>
-                </a:solidFill>
-              </a:defRPr>
-            </a:pPr>
-            <a:r>
-              <a:t>✔  Memory-Optimized DOM &amp; Node</a:t>
-            </a:r>
-          </a:p>
-          <a:p>
-            <a:pPr>
-              <a:spcAft>
-                <a:spcPts val="1000"/>
-              </a:spcAft>
-              <a:defRPr sz="1100">
-                <a:solidFill>
-                  <a:srgbClr val="E4E4E7"/>
-                </a:solidFill>
-              </a:defRPr>
-            </a:pPr>
-            <a:r>
-              <a:t>Event delegation, LocalStorage state sync, and asynchronous FileSystem I/O.</a:t>
+              <a:t>Action: Type 'torvalds' or click popular developer tags</a:t>
+            </a:r>
+          </a:p>
+          <a:p>
+            <a:pPr>
+              <a:defRPr sz="950">
+                <a:solidFill>
+                  <a:srgbClr val="A1A1AA"/>
+                </a:solidFill>
+              </a:defRPr>
+            </a:pPr>
+            <a:r>
+              <a:t>Under the Hood: Promise.all concurrent API fetch executes; Network tab shows parallel user &amp; repo responses.</a:t>
             </a:r>
           </a:p>
         </p:txBody>
@@ -7378,8 +8212,8 @@
         </p:nvSpPr>
         <p:spPr>
           <a:xfrm>
-            <a:off x="6217920" y="1554480"/>
-            <a:ext cx="5242255" cy="4754880"/>
+            <a:off x="6172200" y="1463040"/>
+            <a:ext cx="5257800" cy="1463040"/>
           </a:xfrm>
           <a:prstGeom prst="roundRect">
             <a:avLst/>
@@ -7423,8 +8257,8 @@
         </p:nvSpPr>
         <p:spPr>
           <a:xfrm>
-            <a:off x="6492240" y="1737360"/>
-            <a:ext cx="4663440" cy="4297680"/>
+            <a:off x="6309360" y="1554480"/>
+            <a:ext cx="4983480" cy="1280160"/>
           </a:xfrm>
           <a:prstGeom prst="rect">
             <a:avLst/>
@@ -7439,46 +8273,126 @@
           <a:p>
             <a:pPr>
               <a:spcAft>
-                <a:spcPts val="1600"/>
-              </a:spcAft>
-              <a:defRPr sz="1800" b="1">
+                <a:spcPts val="200"/>
+              </a:spcAft>
+              <a:defRPr sz="1200" b="1">
+                <a:solidFill>
+                  <a:srgbClr val="FCD34D"/>
+                </a:solidFill>
+              </a:defRPr>
+            </a:pPr>
+            <a:r>
+              <a:t>Step 2: Analytics Cards  (app.js: L228)</a:t>
+            </a:r>
+          </a:p>
+          <a:p>
+            <a:pPr>
+              <a:spcAft>
+                <a:spcPts val="200"/>
+              </a:spcAft>
+              <a:defRPr sz="1000" b="1">
                 <a:solidFill>
                   <a:srgbClr val="FFFFFF"/>
                 </a:solidFill>
               </a:defRPr>
             </a:pPr>
             <a:r>
-              <a:t>Week 2: React Deep Dive Focus</a:t>
-            </a:r>
-          </a:p>
+              <a:t>Action: Inspect Total Stars, Forks &amp; Language badges</a:t>
+            </a:r>
+          </a:p>
+          <a:p>
+            <a:pPr>
+              <a:defRPr sz="950">
+                <a:solidFill>
+                  <a:srgbClr val="A1A1AA"/>
+                </a:solidFill>
+              </a:defRPr>
+            </a:pPr>
+            <a:r>
+              <a:t>Under the Hood: .reduce() aggregates 100+ repos into single total numbers in 1 linear pass.</a:t>
+            </a:r>
+          </a:p>
+        </p:txBody>
+      </p:sp>
+      <p:sp>
+        <p:nvSpPr>
+          <p:cNvPr id="10" name="Rounded Rectangle 9"/>
+          <p:cNvSpPr/>
+          <p:nvPr/>
+        </p:nvSpPr>
+        <p:spPr>
+          <a:xfrm>
+            <a:off x="731520" y="3063240"/>
+            <a:ext cx="5257800" cy="1463040"/>
+          </a:xfrm>
+          <a:prstGeom prst="roundRect">
+            <a:avLst/>
+          </a:prstGeom>
+          <a:solidFill>
+            <a:srgbClr val="1A1A1E"/>
+          </a:solidFill>
+          <a:ln w="12700">
+            <a:solidFill>
+              <a:srgbClr val="2A2A32"/>
+            </a:solidFill>
+          </a:ln>
+        </p:spPr>
+        <p:style>
+          <a:lnRef idx="1">
+            <a:schemeClr val="accent1"/>
+          </a:lnRef>
+          <a:fillRef idx="3">
+            <a:schemeClr val="accent1"/>
+          </a:fillRef>
+          <a:effectRef idx="2">
+            <a:schemeClr val="accent1"/>
+          </a:effectRef>
+          <a:fontRef idx="minor">
+            <a:schemeClr val="lt1"/>
+          </a:fontRef>
+        </p:style>
+        <p:txBody>
+          <a:bodyPr rtlCol="0" anchor="ctr"/>
+          <a:lstStyle/>
+          <a:p>
+            <a:pPr algn="ctr"/>
+          </a:p>
+        </p:txBody>
+      </p:sp>
+      <p:sp>
+        <p:nvSpPr>
+          <p:cNvPr id="11" name="TextBox 10"/>
+          <p:cNvSpPr txBox="1"/>
+          <p:nvPr/>
+        </p:nvSpPr>
+        <p:spPr>
+          <a:xfrm>
+            <a:off x="868680" y="3154680"/>
+            <a:ext cx="4983480" cy="1280160"/>
+          </a:xfrm>
+          <a:prstGeom prst="rect">
+            <a:avLst/>
+          </a:prstGeom>
+          <a:noFill/>
+        </p:spPr>
+        <p:txBody>
+          <a:bodyPr wrap="square" lIns="0" tIns="0" rIns="0" bIns="0">
+            <a:spAutoFit/>
+          </a:bodyPr>
+          <a:lstStyle/>
           <a:p>
             <a:pPr>
               <a:spcAft>
                 <a:spcPts val="200"/>
               </a:spcAft>
-              <a:defRPr sz="1250" b="1">
-                <a:solidFill>
-                  <a:srgbClr val="F59E0B"/>
-                </a:solidFill>
-              </a:defRPr>
-            </a:pPr>
-            <a:r>
-              <a:t>🚀  Declarative UI Mindset</a:t>
-            </a:r>
-          </a:p>
-          <a:p>
-            <a:pPr>
-              <a:spcAft>
-                <a:spcPts val="1000"/>
-              </a:spcAft>
-              <a:defRPr sz="1100">
-                <a:solidFill>
-                  <a:srgbClr val="E4E4E7"/>
-                </a:solidFill>
-              </a:defRPr>
-            </a:pPr>
-            <a:r>
-              <a:t>Transitioning from imperative DOM manipulation to Declarative React Component States.</a:t>
+              <a:defRPr sz="1200" b="1">
+                <a:solidFill>
+                  <a:srgbClr val="FCD34D"/>
+                </a:solidFill>
+              </a:defRPr>
+            </a:pPr>
+            <a:r>
+              <a:t>Step 3: Live Filters  (app.js: L273)</a:t>
             </a:r>
           </a:p>
           <a:p>
@@ -7486,59 +8400,109 @@
               <a:spcAft>
                 <a:spcPts val="200"/>
               </a:spcAft>
-              <a:defRPr sz="1250" b="1">
-                <a:solidFill>
-                  <a:srgbClr val="F59E0B"/>
-                </a:solidFill>
-              </a:defRPr>
-            </a:pPr>
-            <a:r>
-              <a:t>🚀  JSX &amp; Virtual DOM Architecture</a:t>
-            </a:r>
-          </a:p>
-          <a:p>
-            <a:pPr>
-              <a:spcAft>
-                <a:spcPts val="1000"/>
-              </a:spcAft>
-              <a:defRPr sz="1100">
-                <a:solidFill>
-                  <a:srgbClr val="E4E4E7"/>
-                </a:solidFill>
-              </a:defRPr>
-            </a:pPr>
-            <a:r>
-              <a:t>Using ES6+ array pipelines (.map()) directly in JSX component trees.</a:t>
-            </a:r>
-          </a:p>
+              <a:defRPr sz="1000" b="1">
+                <a:solidFill>
+                  <a:srgbClr val="FFFFFF"/>
+                </a:solidFill>
+              </a:defRPr>
+            </a:pPr>
+            <a:r>
+              <a:t>Action: Type keywords in filter box &amp; select language</a:t>
+            </a:r>
+          </a:p>
+          <a:p>
+            <a:pPr>
+              <a:defRPr sz="950">
+                <a:solidFill>
+                  <a:srgbClr val="A1A1AA"/>
+                </a:solidFill>
+              </a:defRPr>
+            </a:pPr>
+            <a:r>
+              <a:t>Under the Hood: Spread operator maintains immutability while .filter() updates grid without reloading.</a:t>
+            </a:r>
+          </a:p>
+        </p:txBody>
+      </p:sp>
+      <p:sp>
+        <p:nvSpPr>
+          <p:cNvPr id="12" name="Rounded Rectangle 11"/>
+          <p:cNvSpPr/>
+          <p:nvPr/>
+        </p:nvSpPr>
+        <p:spPr>
+          <a:xfrm>
+            <a:off x="6172200" y="3063240"/>
+            <a:ext cx="5257800" cy="1463040"/>
+          </a:xfrm>
+          <a:prstGeom prst="roundRect">
+            <a:avLst/>
+          </a:prstGeom>
+          <a:solidFill>
+            <a:srgbClr val="1A1A1E"/>
+          </a:solidFill>
+          <a:ln w="12700">
+            <a:solidFill>
+              <a:srgbClr val="2A2A32"/>
+            </a:solidFill>
+          </a:ln>
+        </p:spPr>
+        <p:style>
+          <a:lnRef idx="1">
+            <a:schemeClr val="accent1"/>
+          </a:lnRef>
+          <a:fillRef idx="3">
+            <a:schemeClr val="accent1"/>
+          </a:fillRef>
+          <a:effectRef idx="2">
+            <a:schemeClr val="accent1"/>
+          </a:effectRef>
+          <a:fontRef idx="minor">
+            <a:schemeClr val="lt1"/>
+          </a:fontRef>
+        </p:style>
+        <p:txBody>
+          <a:bodyPr rtlCol="0" anchor="ctr"/>
+          <a:lstStyle/>
+          <a:p>
+            <a:pPr algn="ctr"/>
+          </a:p>
+        </p:txBody>
+      </p:sp>
+      <p:sp>
+        <p:nvSpPr>
+          <p:cNvPr id="13" name="TextBox 12"/>
+          <p:cNvSpPr txBox="1"/>
+          <p:nvPr/>
+        </p:nvSpPr>
+        <p:spPr>
+          <a:xfrm>
+            <a:off x="6309360" y="3154680"/>
+            <a:ext cx="4983480" cy="1280160"/>
+          </a:xfrm>
+          <a:prstGeom prst="rect">
+            <a:avLst/>
+          </a:prstGeom>
+          <a:noFill/>
+        </p:spPr>
+        <p:txBody>
+          <a:bodyPr wrap="square" lIns="0" tIns="0" rIns="0" bIns="0">
+            <a:spAutoFit/>
+          </a:bodyPr>
+          <a:lstStyle/>
           <a:p>
             <a:pPr>
               <a:spcAft>
                 <a:spcPts val="200"/>
               </a:spcAft>
-              <a:defRPr sz="1250" b="1">
-                <a:solidFill>
-                  <a:srgbClr val="F59E0B"/>
-                </a:solidFill>
-              </a:defRPr>
-            </a:pPr>
-            <a:r>
-              <a:t>🚀  State Immutability &amp; Hooks</a:t>
-            </a:r>
-          </a:p>
-          <a:p>
-            <a:pPr>
-              <a:spcAft>
-                <a:spcPts val="1000"/>
-              </a:spcAft>
-              <a:defRPr sz="1100">
-                <a:solidFill>
-                  <a:srgbClr val="E4E4E7"/>
-                </a:solidFill>
-              </a:defRPr>
-            </a:pPr>
-            <a:r>
-              <a:t>Managing state with useState and useEffect cleanly using spread operators (...state).</a:t>
+              <a:defRPr sz="1200" b="1">
+                <a:solidFill>
+                  <a:srgbClr val="FCD34D"/>
+                </a:solidFill>
+              </a:defRPr>
+            </a:pPr>
+            <a:r>
+              <a:t>Step 4: Bookmark &amp; Storage  (app.js: L369)</a:t>
             </a:r>
           </a:p>
           <a:p>
@@ -7546,29 +8510,246 @@
               <a:spcAft>
                 <a:spcPts val="200"/>
               </a:spcAft>
-              <a:defRPr sz="1250" b="1">
-                <a:solidFill>
-                  <a:srgbClr val="F59E0B"/>
-                </a:solidFill>
-              </a:defRPr>
-            </a:pPr>
-            <a:r>
-              <a:t>🚀  Target Deliverable</a:t>
-            </a:r>
-          </a:p>
-          <a:p>
-            <a:pPr>
-              <a:spcAft>
-                <a:spcPts val="1000"/>
-              </a:spcAft>
-              <a:defRPr sz="1100">
-                <a:solidFill>
-                  <a:srgbClr val="E4E4E7"/>
-                </a:solidFill>
-              </a:defRPr>
-            </a:pPr>
-            <a:r>
-              <a:t>Interactive Tic-Tac-Toe App with Undo/Redo &amp; Time-Travel history.</a:t>
+              <a:defRPr sz="1000" b="1">
+                <a:solidFill>
+                  <a:srgbClr val="FFFFFF"/>
+                </a:solidFill>
+              </a:defRPr>
+            </a:pPr>
+            <a:r>
+              <a:t>Action: Click 'Save to Bookmarks' &amp; inspect Tab</a:t>
+            </a:r>
+          </a:p>
+          <a:p>
+            <a:pPr>
+              <a:defRPr sz="950">
+                <a:solidFill>
+                  <a:srgbClr val="A1A1AA"/>
+                </a:solidFill>
+              </a:defRPr>
+            </a:pPr>
+            <a:r>
+              <a:t>Under the Hood: JSON.stringify saves to localStorage; badge count updates; toast animates via setTimeout.</a:t>
+            </a:r>
+          </a:p>
+        </p:txBody>
+      </p:sp>
+      <p:sp>
+        <p:nvSpPr>
+          <p:cNvPr id="14" name="Rounded Rectangle 13"/>
+          <p:cNvSpPr/>
+          <p:nvPr/>
+        </p:nvSpPr>
+        <p:spPr>
+          <a:xfrm>
+            <a:off x="731520" y="4663440"/>
+            <a:ext cx="5257800" cy="1463040"/>
+          </a:xfrm>
+          <a:prstGeom prst="roundRect">
+            <a:avLst/>
+          </a:prstGeom>
+          <a:solidFill>
+            <a:srgbClr val="1A1A1E"/>
+          </a:solidFill>
+          <a:ln w="12700">
+            <a:solidFill>
+              <a:srgbClr val="2A2A32"/>
+            </a:solidFill>
+          </a:ln>
+        </p:spPr>
+        <p:style>
+          <a:lnRef idx="1">
+            <a:schemeClr val="accent1"/>
+          </a:lnRef>
+          <a:fillRef idx="3">
+            <a:schemeClr val="accent1"/>
+          </a:fillRef>
+          <a:effectRef idx="2">
+            <a:schemeClr val="accent1"/>
+          </a:effectRef>
+          <a:fontRef idx="minor">
+            <a:schemeClr val="lt1"/>
+          </a:fontRef>
+        </p:style>
+        <p:txBody>
+          <a:bodyPr rtlCol="0" anchor="ctr"/>
+          <a:lstStyle/>
+          <a:p>
+            <a:pPr algn="ctr"/>
+          </a:p>
+        </p:txBody>
+      </p:sp>
+      <p:sp>
+        <p:nvSpPr>
+          <p:cNvPr id="15" name="TextBox 14"/>
+          <p:cNvSpPr txBox="1"/>
+          <p:nvPr/>
+        </p:nvSpPr>
+        <p:spPr>
+          <a:xfrm>
+            <a:off x="868680" y="4754879"/>
+            <a:ext cx="4983480" cy="1280160"/>
+          </a:xfrm>
+          <a:prstGeom prst="rect">
+            <a:avLst/>
+          </a:prstGeom>
+          <a:noFill/>
+        </p:spPr>
+        <p:txBody>
+          <a:bodyPr wrap="square" lIns="0" tIns="0" rIns="0" bIns="0">
+            <a:spAutoFit/>
+          </a:bodyPr>
+          <a:lstStyle/>
+          <a:p>
+            <a:pPr>
+              <a:spcAft>
+                <a:spcPts val="200"/>
+              </a:spcAft>
+              <a:defRPr sz="1200" b="1">
+                <a:solidFill>
+                  <a:srgbClr val="FCD34D"/>
+                </a:solidFill>
+              </a:defRPr>
+            </a:pPr>
+            <a:r>
+              <a:t>Step 5: Event Delegation  (app.js: L141)</a:t>
+            </a:r>
+          </a:p>
+          <a:p>
+            <a:pPr>
+              <a:spcAft>
+                <a:spcPts val="200"/>
+              </a:spcAft>
+              <a:defRPr sz="1000" b="1">
+                <a:solidFill>
+                  <a:srgbClr val="FFFFFF"/>
+                </a:solidFill>
+              </a:defRPr>
+            </a:pPr>
+            <a:r>
+              <a:t>Action: Click 'Inspect' or 'Remove' in Bookmarks tab</a:t>
+            </a:r>
+          </a:p>
+          <a:p>
+            <a:pPr>
+              <a:defRPr sz="950">
+                <a:solidFill>
+                  <a:srgbClr val="A1A1AA"/>
+                </a:solidFill>
+              </a:defRPr>
+            </a:pPr>
+            <a:r>
+              <a:t>Under the Hood: 1 single parent listener intercepts clicks via event.target.closest(). Zero memory leaks!</a:t>
+            </a:r>
+          </a:p>
+        </p:txBody>
+      </p:sp>
+      <p:sp>
+        <p:nvSpPr>
+          <p:cNvPr id="16" name="Rounded Rectangle 15"/>
+          <p:cNvSpPr/>
+          <p:nvPr/>
+        </p:nvSpPr>
+        <p:spPr>
+          <a:xfrm>
+            <a:off x="6172200" y="4663440"/>
+            <a:ext cx="5257800" cy="1463040"/>
+          </a:xfrm>
+          <a:prstGeom prst="roundRect">
+            <a:avLst/>
+          </a:prstGeom>
+          <a:solidFill>
+            <a:srgbClr val="1A1A1E"/>
+          </a:solidFill>
+          <a:ln w="12700">
+            <a:solidFill>
+              <a:srgbClr val="2A2A32"/>
+            </a:solidFill>
+          </a:ln>
+        </p:spPr>
+        <p:style>
+          <a:lnRef idx="1">
+            <a:schemeClr val="accent1"/>
+          </a:lnRef>
+          <a:fillRef idx="3">
+            <a:schemeClr val="accent1"/>
+          </a:fillRef>
+          <a:effectRef idx="2">
+            <a:schemeClr val="accent1"/>
+          </a:effectRef>
+          <a:fontRef idx="minor">
+            <a:schemeClr val="lt1"/>
+          </a:fontRef>
+        </p:style>
+        <p:txBody>
+          <a:bodyPr rtlCol="0" anchor="ctr"/>
+          <a:lstStyle/>
+          <a:p>
+            <a:pPr algn="ctr"/>
+          </a:p>
+        </p:txBody>
+      </p:sp>
+      <p:sp>
+        <p:nvSpPr>
+          <p:cNvPr id="17" name="TextBox 16"/>
+          <p:cNvSpPr txBox="1"/>
+          <p:nvPr/>
+        </p:nvSpPr>
+        <p:spPr>
+          <a:xfrm>
+            <a:off x="6309360" y="4754879"/>
+            <a:ext cx="4983480" cy="1280160"/>
+          </a:xfrm>
+          <a:prstGeom prst="rect">
+            <a:avLst/>
+          </a:prstGeom>
+          <a:noFill/>
+        </p:spPr>
+        <p:txBody>
+          <a:bodyPr wrap="square" lIns="0" tIns="0" rIns="0" bIns="0">
+            <a:spAutoFit/>
+          </a:bodyPr>
+          <a:lstStyle/>
+          <a:p>
+            <a:pPr>
+              <a:spcAft>
+                <a:spcPts val="200"/>
+              </a:spcAft>
+              <a:defRPr sz="1200" b="1">
+                <a:solidFill>
+                  <a:srgbClr val="FCD34D"/>
+                </a:solidFill>
+              </a:defRPr>
+            </a:pPr>
+            <a:r>
+              <a:t>Step 6: Cache Verification  (app.js: L166)</a:t>
+            </a:r>
+          </a:p>
+          <a:p>
+            <a:pPr>
+              <a:spcAft>
+                <a:spcPts val="200"/>
+              </a:spcAft>
+              <a:defRPr sz="1000" b="1">
+                <a:solidFill>
+                  <a:srgbClr val="FFFFFF"/>
+                </a:solidFill>
+              </a:defRPr>
+            </a:pPr>
+            <a:r>
+              <a:t>Action: Search 'torvalds' again in Explorer tab</a:t>
+            </a:r>
+          </a:p>
+          <a:p>
+            <a:pPr>
+              <a:defRPr sz="950">
+                <a:solidFill>
+                  <a:srgbClr val="A1A1AA"/>
+                </a:solidFill>
+              </a:defRPr>
+            </a:pPr>
+            <a:r>
+              <a:t>Under the Hood: In-Memory Map cache loads profile in 0ms instant speed; 'Cached ⚡' indicator activates.</a:t>
             </a:r>
           </a:p>
         </p:txBody>

</xml_diff>